<commit_message>
docs: align agent hardening guidance and remove rate caps
</commit_message>
<xml_diff>
--- a/docs/presentations/Agent高可用加固.pptx
+++ b/docs/presentations/Agent高可用加固.pptx
@@ -2,13 +2,13 @@
 <file path=ppt/presentation.xml><?xml version="1.0" encoding="utf-8"?>
 <p:presentation xmlns:p="http://schemas.openxmlformats.org/presentationml/2006/main">
   <p:sldMasterIdLst>
-    <p:sldMasterId xmlns:r="http://schemas.openxmlformats.org/officeDocument/2006/relationships" id="2147483648" r:id="Ra38dafb9b9c04909"/>
+    <p:sldMasterId xmlns:r="http://schemas.openxmlformats.org/officeDocument/2006/relationships" id="2147483648" r:id="R52b20cd093614509"/>
   </p:sldMasterIdLst>
   <p:notesMasterIdLst>
-    <p:notesMasterId xmlns:r="http://schemas.openxmlformats.org/officeDocument/2006/relationships" r:id="R39d0bb2c99054db6"/>
+    <p:notesMasterId xmlns:r="http://schemas.openxmlformats.org/officeDocument/2006/relationships" r:id="Rbe278d6521514525"/>
   </p:notesMasterIdLst>
   <p:sldIdLst>
-    <p:sldId xmlns:r="http://schemas.openxmlformats.org/officeDocument/2006/relationships" id="256" r:id="R9846a9ee71894317"/>
+    <p:sldId xmlns:r="http://schemas.openxmlformats.org/officeDocument/2006/relationships" id="256" r:id="R0ac4de4f1c2c451a"/>
   </p:sldIdLst>
   <p:sldSz cx="15240000" cy="8572500"/>
   <p:notesSz cx="6858000" cy="9144000"/>
@@ -457,7 +457,7 @@
           </a:p>
           <a:p xmlns:a="http://schemas.openxmlformats.org/drawingml/2006/main">
             <a:r>
-              <a:t>本页沿用当前ChatService到agentService再到DomainAgent的调用关系，以及现有的异步标记、Execution挂起和终态回调。异步链以现有runId关联，不要求增加一个远端任务ID作为前置条件。图中连接并发、帧速率、组帧期限、解析任务P和总驻留字节等为按现有代码缺口设计的加固机制，不宣称已经全部实现。长任务行描述runId关联的异步执行方案，启用状态以生产配置为准。新增保护与协议能力需实施和验证。</a:t>
+              <a:t>本页沿用当前ChatService到agentService再到DomainAgent的调用关系，以及现有的异步标记、Execution挂起和终态回调。异步链以现有runId关联，不要求增加一个远端任务ID作为前置条件。图中连接并发、单帧大小、组帧期限、解析任务P和总驻留字节等为按现有代码缺口设计的加固机制，不宣称已经全部实现。长任务行描述runId关联的异步执行方案，启用状态以生产配置为准。新增保护与协议能力需实施和验证。</a:t>
             </a:r>
           </a:p>
           <a:p xmlns:a="http://schemas.openxmlformats.org/drawingml/2006/main">
@@ -557,7 +557,7 @@
           </a:p>
           <a:p xmlns:a="http://schemas.openxmlformats.org/drawingml/2006/main">
             <a:r>
-              <a:t>超大帧、高频帧、长帧及长文本可能导致解析/序列化工作量、驻留缓冲、正文与编码副本增长，进而CPU、堆内存与GC压力升高，不把代码模式直接写为已复现OOM。现有帧和回调上限保留，拟补充速率、队列字节、处理并行和累计正文等总预算。单帧UTF-8字节、组帧期限、帧速率/字节速率及突发量须三方签认并按版本联测。持续有字节但不形成完整逻辑帧时，组帧期限从帧起始计时，不随每个chunk无限刷新。</a:t>
+              <a:t>超大帧、高频帧、长帧及长文本可能导致解析/序列化工作量、驻留缓冲、正文与编码副本增长，进而CPU、堆内存与GC压力升高，不把代码模式直接写为已复现OOM。现有帧和回调上限保留，拟补充队列字节、处理并行和累计正文等总预算。单帧UTF-8字节上限、组帧期限及异常处理方式须三方签认并按版本联测。持续有字节但不形成完整逻辑帧时，组帧期限从帧起始计时，不随每个chunk无限刷新。</a:t>
             </a:r>
           </a:p>
           <a:p xmlns:a="http://schemas.openxmlformats.org/drawingml/2006/main">
@@ -707,127 +707,27 @@
           </a:p>
           <a:p xmlns:a="http://schemas.openxmlformats.org/drawingml/2006/main">
             <a:r>
-              <a:t>01  并发限制与普通流超时</a:t>
-            </a:r>
-          </a:p>
-          <a:p xmlns:a="http://schemas.openxmlformats.org/drawingml/2006/main">
-            <a:r>
-              <a:t>实例、单Agent分别限并发，满则拒绝。</a:t>
-            </a:r>
-          </a:p>
-          <a:p xmlns:a="http://schemas.openxmlformats.org/drawingml/2006/main">
-            <a:r>
-              <a:t>各阶段有超时，整次调用另设总时限。</a:t>
-            </a:r>
-          </a:p>
-          <a:p xmlns:a="http://schemas.openxmlformats.org/drawingml/2006/main">
-            <a:r>
-              <a:t>超时后停止等待，释放本地连接与名额。</a:t>
-            </a:r>
-          </a:p>
-          <a:p xmlns:a="http://schemas.openxmlformats.org/drawingml/2006/main">
-            <a:r>
               <a:t/>
             </a:r>
           </a:p>
           <a:p xmlns:a="http://schemas.openxmlformats.org/drawingml/2006/main">
             <a:r>
-              <a:t>02  异步任务使用独立等待期限</a:t>
-            </a:r>
-          </a:p>
-          <a:p xmlns:a="http://schemas.openxmlformats.org/drawingml/2006/main">
-            <a:r>
-              <a:t>标记返回前，按普通流的期限等待。</a:t>
-            </a:r>
-          </a:p>
-          <a:p xmlns:a="http://schemas.openxmlformats.org/drawingml/2006/main">
-            <a:r>
-              <a:t>收到标记后结束HTTP，后台继续运行。</a:t>
-            </a:r>
-          </a:p>
-          <a:p xmlns:a="http://schemas.openxmlformats.org/drawingml/2006/main">
-            <a:r>
-              <a:t>单次回调处理限时，按runId匹配。</a:t>
-            </a:r>
-          </a:p>
-          <a:p xmlns:a="http://schemas.openxmlformats.org/drawingml/2006/main">
-            <a:r>
-              <a:t>到期结束本地任务，远端状态另确认。</a:t>
-            </a:r>
-          </a:p>
-          <a:p xmlns:a="http://schemas.openxmlformats.org/drawingml/2006/main">
-            <a:r>
-              <a:t/>
-            </a:r>
-          </a:p>
-          <a:p xmlns:a="http://schemas.openxmlformats.org/drawingml/2006/main">
-            <a:r>
-              <a:t>03  后台任务限量与取消超时</a:t>
-            </a:r>
-          </a:p>
-          <a:p xmlns:a="http://schemas.openxmlformats.org/drawingml/2006/main">
-            <a:r>
-              <a:t>按用户、租户和Agent限制未完成任务数。</a:t>
-            </a:r>
-          </a:p>
-          <a:p xmlns:a="http://schemas.openxmlformats.org/drawingml/2006/main">
-            <a:r>
-              <a:t>达到上限，暂不发起新的后台任务。</a:t>
-            </a:r>
-          </a:p>
-          <a:p xmlns:a="http://schemas.openxmlformats.org/drawingml/2006/main">
-            <a:r>
-              <a:t>取消超时先查任务状态，不自动重跑。</a:t>
-            </a:r>
-          </a:p>
-          <a:p xmlns:a="http://schemas.openxmlformats.org/drawingml/2006/main">
-            <a:r>
-              <a:t/>
-            </a:r>
-          </a:p>
-          <a:p xmlns:a="http://schemas.openxmlformats.org/drawingml/2006/main">
-            <a:r>
-              <a:t>04  限制处理量和内存增长</a:t>
-            </a:r>
-          </a:p>
-          <a:p xmlns:a="http://schemas.openxmlformats.org/drawingml/2006/main">
-            <a:r>
-              <a:t>队列同时限制条数和字节数。</a:t>
-            </a:r>
-          </a:p>
-          <a:p xmlns:a="http://schemas.openxmlformats.org/drawingml/2006/main">
-            <a:r>
-              <a:t>最多P个任务同时处理，限制JSON层数。</a:t>
-            </a:r>
-          </a:p>
-          <a:p xmlns:a="http://schemas.openxmlformats.org/drawingml/2006/main">
-            <a:r>
-              <a:t>正文和编码副本都计入内存上限。</a:t>
-            </a:r>
-          </a:p>
-          <a:p xmlns:a="http://schemas.openxmlformats.org/drawingml/2006/main">
-            <a:r>
-              <a:t/>
-            </a:r>
-          </a:p>
-          <a:p xmlns:a="http://schemas.openxmlformats.org/drawingml/2006/main">
-            <a:r>
-              <a:t>05  积压先暂停，超限明确报错</a:t>
-            </a:r>
-          </a:p>
-          <a:p xmlns:a="http://schemas.openxmlformats.org/drawingml/2006/main">
-            <a:r>
-              <a:t>队列接近上限时暂停接收，减少后恢复。</a:t>
-            </a:r>
-          </a:p>
-          <a:p xmlns:a="http://schemas.openxmlformats.org/drawingml/2006/main">
-            <a:r>
-              <a:t>超过上限或暂停太久，停止本次调用。</a:t>
-            </a:r>
-          </a:p>
-          <a:p xmlns:a="http://schemas.openxmlformats.org/drawingml/2006/main">
-            <a:r>
-              <a:t>不丢帧、不截断后再向前端报告成功。</a:t>
+              <a:t>右侧讲解顺序</a:t>
+            </a:r>
+          </a:p>
+          <a:p xmlns:a="http://schemas.openxmlformats.org/drawingml/2006/main">
+            <a:r>
+              <a:t>① 连接与长任务控制：并发准入、普通流各阶段和整体期限、异步标记及后台任务限量与独立等待期限。</a:t>
+            </a:r>
+          </a:p>
+          <a:p xmlns:a="http://schemas.openxmlformats.org/drawingml/2006/main">
+            <a:r>
+              <a:t>② 响应结果消费控制：单帧接收、排队与处理、正文内存。两组顺序与左图一致。</a:t>
+            </a:r>
+          </a:p>
+          <a:p xmlns:a="http://schemas.openxmlformats.org/drawingml/2006/main">
+            <a:r>
+              <a:t>具体限制与暂停策略须与下游协议签认；达到硬上限或暂停超时应明确失败，不能静默丢帧或截断后报成功。单次回调处理限时、JSON结构复杂度限制、远端查询和取消确认的实现及验证要求保留在上述详细备注中。</a:t>
             </a:r>
           </a:p>
         </p:txBody>
@@ -895,7 +795,7 @@
   </p:cSld>
   <p:clrMap bg1="lt1" tx1="dk1" bg2="lt2" tx2="dk2" accent1="accent1" accent2="accent2" accent3="accent3" accent4="accent4" accent5="accent5" accent6="accent6" hlink="hlink" folHlink="folHlink"/>
   <p:sldLayoutIdLst>
-    <p:sldLayoutId xmlns:r="http://schemas.openxmlformats.org/officeDocument/2006/relationships" id="2147483649" r:id="Rc4cec6f1bee3463b"/>
+    <p:sldLayoutId xmlns:r="http://schemas.openxmlformats.org/officeDocument/2006/relationships" id="2147483649" r:id="R0dfa498bb8f84a06"/>
   </p:sldLayoutIdLst>
   <p:txStyles>
     <p:titleStyle>
@@ -1475,6 +1375,7 @@
           <a:lstStyle xmlns:a="http://schemas.openxmlformats.org/drawingml/2006/main"/>
           <a:p xmlns:a="http://schemas.openxmlformats.org/drawingml/2006/main">
             <a:pPr algn="l">
+              <a:buNone/>
               <a:defRPr sz="3225" b="1">
                 <a:solidFill>
                   <a:srgbClr val="163A63"/>
@@ -1532,6 +1433,7 @@
           <a:lstStyle xmlns:a="http://schemas.openxmlformats.org/drawingml/2006/main"/>
           <a:p xmlns:a="http://schemas.openxmlformats.org/drawingml/2006/main">
             <a:pPr algn="l">
+              <a:buNone/>
               <a:defRPr sz="1875" b="0">
                 <a:solidFill>
                   <a:srgbClr val="2166B0"/>
@@ -1620,6 +1522,7 @@
           <a:lstStyle xmlns:a="http://schemas.openxmlformats.org/drawingml/2006/main"/>
           <a:p xmlns:a="http://schemas.openxmlformats.org/drawingml/2006/main">
             <a:pPr algn="l">
+              <a:buNone/>
               <a:defRPr sz="2100" b="1">
                 <a:solidFill>
                   <a:srgbClr val="163A63"/>
@@ -1677,6 +1580,7 @@
           <a:lstStyle xmlns:a="http://schemas.openxmlformats.org/drawingml/2006/main"/>
           <a:p xmlns:a="http://schemas.openxmlformats.org/drawingml/2006/main">
             <a:pPr algn="l">
+              <a:buNone/>
               <a:defRPr sz="2100" b="1">
                 <a:solidFill>
                   <a:srgbClr val="163A63"/>
@@ -1734,6 +1638,7 @@
           <a:lstStyle xmlns:a="http://schemas.openxmlformats.org/drawingml/2006/main"/>
           <a:p xmlns:a="http://schemas.openxmlformats.org/drawingml/2006/main">
             <a:pPr algn="l">
+              <a:buNone/>
               <a:defRPr sz="1875" b="1">
                 <a:solidFill>
                   <a:srgbClr val="2166B0"/>
@@ -2110,6 +2015,7 @@
           <a:lstStyle xmlns:a="http://schemas.openxmlformats.org/drawingml/2006/main"/>
           <a:p xmlns:a="http://schemas.openxmlformats.org/drawingml/2006/main">
             <a:pPr algn="ctr">
+              <a:buNone/>
               <a:defRPr sz="1725" b="1">
                 <a:solidFill>
                   <a:srgbClr val="163A63"/>
@@ -2199,6 +2105,7 @@
           <a:lstStyle xmlns:a="http://schemas.openxmlformats.org/drawingml/2006/main"/>
           <a:p xmlns:a="http://schemas.openxmlformats.org/drawingml/2006/main">
             <a:pPr algn="ctr">
+              <a:buNone/>
               <a:defRPr sz="1500" b="1">
                 <a:solidFill>
                   <a:srgbClr val="163A63"/>
@@ -2222,6 +2129,7 @@
           </a:p>
           <a:p xmlns:a="http://schemas.openxmlformats.org/drawingml/2006/main">
             <a:pPr algn="ctr">
+              <a:buNone/>
               <a:defRPr sz="1500" b="1">
                 <a:solidFill>
                   <a:srgbClr val="163A63"/>
@@ -2303,7 +2211,7 @@
       </p:sp>
       <p:cxnSp>
         <p:nvCxnSpPr>
-          <p:cNvPr id="204" name=""/>
+          <p:cNvPr id="549" name=""/>
           <p:cNvCxnSpPr>
             <a:stCxn xmlns:a="http://schemas.openxmlformats.org/drawingml/2006/main" id="20" idx="3"/>
             <a:endCxn xmlns:a="http://schemas.openxmlformats.org/drawingml/2006/main" id="21" idx="1"/>
@@ -2361,6 +2269,7 @@
           <a:lstStyle xmlns:a="http://schemas.openxmlformats.org/drawingml/2006/main"/>
           <a:p xmlns:a="http://schemas.openxmlformats.org/drawingml/2006/main">
             <a:pPr algn="ctr">
+              <a:buNone/>
               <a:defRPr sz="1425" b="0">
                 <a:solidFill>
                   <a:srgbClr val="647D99"/>
@@ -2536,7 +2445,7 @@
       </p:sp>
       <p:cxnSp>
         <p:nvCxnSpPr>
-          <p:cNvPr id="211" name=""/>
+          <p:cNvPr id="556" name=""/>
           <p:cNvCxnSpPr>
             <a:stCxn xmlns:a="http://schemas.openxmlformats.org/drawingml/2006/main" id="27" idx="3"/>
             <a:endCxn xmlns:a="http://schemas.openxmlformats.org/drawingml/2006/main" id="28" idx="1"/>
@@ -2594,6 +2503,7 @@
           <a:lstStyle xmlns:a="http://schemas.openxmlformats.org/drawingml/2006/main"/>
           <a:p xmlns:a="http://schemas.openxmlformats.org/drawingml/2006/main">
             <a:pPr algn="ctr">
+              <a:buNone/>
               <a:defRPr sz="1575" b="1">
                 <a:solidFill>
                   <a:srgbClr val="163A63"/>
@@ -2970,6 +2880,7 @@
           <a:lstStyle xmlns:a="http://schemas.openxmlformats.org/drawingml/2006/main"/>
           <a:p xmlns:a="http://schemas.openxmlformats.org/drawingml/2006/main">
             <a:pPr algn="ctr">
+              <a:buNone/>
               <a:defRPr sz="1725" b="1">
                 <a:solidFill>
                   <a:srgbClr val="163A63"/>
@@ -3051,7 +2962,7 @@
       </p:sp>
       <p:cxnSp>
         <p:nvCxnSpPr>
-          <p:cNvPr id="226" name=""/>
+          <p:cNvPr id="571" name=""/>
           <p:cNvCxnSpPr>
             <a:stCxn xmlns:a="http://schemas.openxmlformats.org/drawingml/2006/main" id="42" idx="3"/>
             <a:endCxn xmlns:a="http://schemas.openxmlformats.org/drawingml/2006/main" id="43" idx="1"/>
@@ -3141,6 +3052,7 @@
           <a:lstStyle xmlns:a="http://schemas.openxmlformats.org/drawingml/2006/main"/>
           <a:p xmlns:a="http://schemas.openxmlformats.org/drawingml/2006/main">
             <a:pPr algn="ctr">
+              <a:buNone/>
               <a:defRPr sz="1650" b="1">
                 <a:solidFill>
                   <a:srgbClr val="2166B0"/>
@@ -3222,7 +3134,7 @@
       </p:sp>
       <p:cxnSp>
         <p:nvCxnSpPr>
-          <p:cNvPr id="231" name=""/>
+          <p:cNvPr id="576" name=""/>
           <p:cNvCxnSpPr>
             <a:stCxn xmlns:a="http://schemas.openxmlformats.org/drawingml/2006/main" id="47" idx="3"/>
             <a:endCxn xmlns:a="http://schemas.openxmlformats.org/drawingml/2006/main" id="48" idx="1"/>
@@ -3280,6 +3192,7 @@
           <a:lstStyle xmlns:a="http://schemas.openxmlformats.org/drawingml/2006/main"/>
           <a:p xmlns:a="http://schemas.openxmlformats.org/drawingml/2006/main">
             <a:pPr algn="ctr">
+              <a:buNone/>
               <a:defRPr sz="1425" b="0">
                 <a:solidFill>
                   <a:srgbClr val="647D99"/>
@@ -3337,6 +3250,7 @@
           <a:lstStyle xmlns:a="http://schemas.openxmlformats.org/drawingml/2006/main"/>
           <a:p xmlns:a="http://schemas.openxmlformats.org/drawingml/2006/main">
             <a:pPr algn="ctr">
+              <a:buNone/>
               <a:defRPr sz="1725" b="1">
                 <a:solidFill>
                   <a:srgbClr val="163A63"/>
@@ -3394,6 +3308,7 @@
           <a:lstStyle xmlns:a="http://schemas.openxmlformats.org/drawingml/2006/main"/>
           <a:p xmlns:a="http://schemas.openxmlformats.org/drawingml/2006/main">
             <a:pPr algn="l">
+              <a:buNone/>
               <a:defRPr sz="1650" b="1">
                 <a:solidFill>
                   <a:srgbClr val="2166B0"/>
@@ -3451,6 +3366,7 @@
           <a:lstStyle xmlns:a="http://schemas.openxmlformats.org/drawingml/2006/main"/>
           <a:p xmlns:a="http://schemas.openxmlformats.org/drawingml/2006/main">
             <a:pPr algn="ctr">
+              <a:buNone/>
               <a:defRPr sz="1575" b="1">
                 <a:solidFill>
                   <a:srgbClr val="163A63"/>
@@ -3508,6 +3424,7 @@
           <a:lstStyle xmlns:a="http://schemas.openxmlformats.org/drawingml/2006/main"/>
           <a:p xmlns:a="http://schemas.openxmlformats.org/drawingml/2006/main">
             <a:pPr algn="ctr">
+              <a:buNone/>
               <a:defRPr sz="1350" b="0">
                 <a:solidFill>
                   <a:srgbClr val="2D4663"/>
@@ -3565,6 +3482,7 @@
           <a:lstStyle xmlns:a="http://schemas.openxmlformats.org/drawingml/2006/main"/>
           <a:p xmlns:a="http://schemas.openxmlformats.org/drawingml/2006/main">
             <a:pPr algn="ctr">
+              <a:buNone/>
               <a:defRPr sz="1575" b="1">
                 <a:solidFill>
                   <a:srgbClr val="163A63"/>
@@ -3622,6 +3540,7 @@
           <a:lstStyle xmlns:a="http://schemas.openxmlformats.org/drawingml/2006/main"/>
           <a:p xmlns:a="http://schemas.openxmlformats.org/drawingml/2006/main">
             <a:pPr algn="ctr">
+              <a:buNone/>
               <a:defRPr sz="1350" b="0">
                 <a:solidFill>
                   <a:srgbClr val="2D4663"/>
@@ -3679,6 +3598,7 @@
           <a:lstStyle xmlns:a="http://schemas.openxmlformats.org/drawingml/2006/main"/>
           <a:p xmlns:a="http://schemas.openxmlformats.org/drawingml/2006/main">
             <a:pPr algn="ctr">
+              <a:buNone/>
               <a:defRPr sz="1575" b="1">
                 <a:solidFill>
                   <a:srgbClr val="163A63"/>
@@ -3736,6 +3656,7 @@
           <a:lstStyle xmlns:a="http://schemas.openxmlformats.org/drawingml/2006/main"/>
           <a:p xmlns:a="http://schemas.openxmlformats.org/drawingml/2006/main">
             <a:pPr algn="ctr">
+              <a:buNone/>
               <a:defRPr sz="1350" b="0">
                 <a:solidFill>
                   <a:srgbClr val="2D4663"/>
@@ -3793,6 +3714,7 @@
           <a:lstStyle xmlns:a="http://schemas.openxmlformats.org/drawingml/2006/main"/>
           <a:p xmlns:a="http://schemas.openxmlformats.org/drawingml/2006/main">
             <a:pPr algn="ctr">
+              <a:buNone/>
               <a:defRPr sz="1575" b="1">
                 <a:solidFill>
                   <a:srgbClr val="163A63"/>
@@ -3850,6 +3772,7 @@
           <a:lstStyle xmlns:a="http://schemas.openxmlformats.org/drawingml/2006/main"/>
           <a:p xmlns:a="http://schemas.openxmlformats.org/drawingml/2006/main">
             <a:pPr algn="ctr">
+              <a:buNone/>
               <a:defRPr sz="1350" b="0">
                 <a:solidFill>
                   <a:srgbClr val="2D4663"/>
@@ -3931,7 +3854,7 @@
       </p:sp>
       <p:cxnSp>
         <p:nvCxnSpPr>
-          <p:cNvPr id="245" name=""/>
+          <p:cNvPr id="590" name=""/>
           <p:cNvCxnSpPr>
             <a:stCxn xmlns:a="http://schemas.openxmlformats.org/drawingml/2006/main" id="61" idx="3"/>
             <a:endCxn xmlns:a="http://schemas.openxmlformats.org/drawingml/2006/main" id="62" idx="1"/>
@@ -4013,7 +3936,7 @@
       </p:sp>
       <p:cxnSp>
         <p:nvCxnSpPr>
-          <p:cNvPr id="248" name=""/>
+          <p:cNvPr id="593" name=""/>
           <p:cNvCxnSpPr>
             <a:stCxn xmlns:a="http://schemas.openxmlformats.org/drawingml/2006/main" id="64" idx="3"/>
             <a:endCxn xmlns:a="http://schemas.openxmlformats.org/drawingml/2006/main" id="65" idx="1"/>
@@ -4095,7 +4018,7 @@
       </p:sp>
       <p:cxnSp>
         <p:nvCxnSpPr>
-          <p:cNvPr id="251" name=""/>
+          <p:cNvPr id="596" name=""/>
           <p:cNvCxnSpPr>
             <a:stCxn xmlns:a="http://schemas.openxmlformats.org/drawingml/2006/main" id="67" idx="3"/>
             <a:endCxn xmlns:a="http://schemas.openxmlformats.org/drawingml/2006/main" id="68" idx="1"/>
@@ -4177,7 +4100,7 @@
       </p:sp>
       <p:cxnSp>
         <p:nvCxnSpPr>
-          <p:cNvPr id="254" name=""/>
+          <p:cNvPr id="599" name=""/>
           <p:cNvCxnSpPr>
             <a:stCxn xmlns:a="http://schemas.openxmlformats.org/drawingml/2006/main" id="70" idx="2"/>
             <a:endCxn xmlns:a="http://schemas.openxmlformats.org/drawingml/2006/main" id="71" idx="0"/>
@@ -4259,7 +4182,7 @@
       </p:sp>
       <p:cxnSp>
         <p:nvCxnSpPr>
-          <p:cNvPr id="257" name=""/>
+          <p:cNvPr id="602" name=""/>
           <p:cNvCxnSpPr>
             <a:stCxn xmlns:a="http://schemas.openxmlformats.org/drawingml/2006/main" id="73" idx="3"/>
             <a:endCxn xmlns:a="http://schemas.openxmlformats.org/drawingml/2006/main" id="74" idx="1"/>
@@ -4341,7 +4264,7 @@
       </p:sp>
       <p:cxnSp>
         <p:nvCxnSpPr>
-          <p:cNvPr id="260" name=""/>
+          <p:cNvPr id="605" name=""/>
           <p:cNvCxnSpPr>
             <a:stCxn xmlns:a="http://schemas.openxmlformats.org/drawingml/2006/main" id="76" idx="0"/>
             <a:endCxn xmlns:a="http://schemas.openxmlformats.org/drawingml/2006/main" id="77" idx="2"/>
@@ -4399,6 +4322,7 @@
           <a:lstStyle xmlns:a="http://schemas.openxmlformats.org/drawingml/2006/main"/>
           <a:p xmlns:a="http://schemas.openxmlformats.org/drawingml/2006/main">
             <a:pPr algn="ctr">
+              <a:buNone/>
               <a:defRPr sz="1425" b="0">
                 <a:solidFill>
                   <a:srgbClr val="2166B0"/>
@@ -4456,6 +4380,7 @@
           <a:lstStyle xmlns:a="http://schemas.openxmlformats.org/drawingml/2006/main"/>
           <a:p xmlns:a="http://schemas.openxmlformats.org/drawingml/2006/main">
             <a:pPr algn="l">
+              <a:buNone/>
               <a:defRPr sz="1650" b="1">
                 <a:solidFill>
                   <a:srgbClr val="2166B0"/>
@@ -4513,6 +4438,7 @@
           <a:lstStyle xmlns:a="http://schemas.openxmlformats.org/drawingml/2006/main"/>
           <a:p xmlns:a="http://schemas.openxmlformats.org/drawingml/2006/main">
             <a:pPr algn="l">
+              <a:buNone/>
               <a:defRPr sz="1350" b="0">
                 <a:solidFill>
                   <a:srgbClr val="647D99"/>
@@ -4664,6 +4590,7 @@
           <a:lstStyle xmlns:a="http://schemas.openxmlformats.org/drawingml/2006/main"/>
           <a:p xmlns:a="http://schemas.openxmlformats.org/drawingml/2006/main">
             <a:pPr algn="ctr">
+              <a:buNone/>
               <a:defRPr sz="1425" b="1">
                 <a:solidFill>
                   <a:srgbClr val="163A63"/>
@@ -4721,6 +4648,7 @@
           <a:lstStyle xmlns:a="http://schemas.openxmlformats.org/drawingml/2006/main"/>
           <a:p xmlns:a="http://schemas.openxmlformats.org/drawingml/2006/main">
             <a:pPr algn="ctr">
+              <a:buNone/>
               <a:defRPr sz="1200" b="0">
                 <a:solidFill>
                   <a:srgbClr val="647D99"/>
@@ -4802,7 +4730,7 @@
       </p:sp>
       <p:cxnSp>
         <p:nvCxnSpPr>
-          <p:cNvPr id="271" name=""/>
+          <p:cNvPr id="616" name=""/>
           <p:cNvCxnSpPr>
             <a:stCxn xmlns:a="http://schemas.openxmlformats.org/drawingml/2006/main" id="87" idx="3"/>
             <a:endCxn xmlns:a="http://schemas.openxmlformats.org/drawingml/2006/main" id="88" idx="1"/>
@@ -5130,6 +5058,7 @@
           <a:lstStyle xmlns:a="http://schemas.openxmlformats.org/drawingml/2006/main"/>
           <a:p xmlns:a="http://schemas.openxmlformats.org/drawingml/2006/main">
             <a:pPr algn="ctr">
+              <a:buNone/>
               <a:defRPr sz="1500" b="1">
                 <a:solidFill>
                   <a:srgbClr val="163A63"/>
@@ -5187,6 +5116,7 @@
           <a:lstStyle xmlns:a="http://schemas.openxmlformats.org/drawingml/2006/main"/>
           <a:p xmlns:a="http://schemas.openxmlformats.org/drawingml/2006/main">
             <a:pPr algn="ctr">
+              <a:buNone/>
               <a:defRPr sz="1275" b="0">
                 <a:solidFill>
                   <a:srgbClr val="647D99"/>
@@ -5244,6 +5174,7 @@
           <a:lstStyle xmlns:a="http://schemas.openxmlformats.org/drawingml/2006/main"/>
           <a:p xmlns:a="http://schemas.openxmlformats.org/drawingml/2006/main">
             <a:pPr algn="ctr">
+              <a:buNone/>
               <a:defRPr sz="1350" b="0">
                 <a:solidFill>
                   <a:srgbClr val="647D99"/>
@@ -5333,6 +5264,7 @@
           <a:lstStyle xmlns:a="http://schemas.openxmlformats.org/drawingml/2006/main"/>
           <a:p xmlns:a="http://schemas.openxmlformats.org/drawingml/2006/main">
             <a:pPr algn="ctr">
+              <a:buNone/>
               <a:defRPr sz="1500" b="1">
                 <a:solidFill>
                   <a:srgbClr val="2166B0"/>
@@ -5390,6 +5322,7 @@
           <a:lstStyle xmlns:a="http://schemas.openxmlformats.org/drawingml/2006/main"/>
           <a:p xmlns:a="http://schemas.openxmlformats.org/drawingml/2006/main">
             <a:pPr algn="ctr">
+              <a:buNone/>
               <a:defRPr sz="1500" b="1">
                 <a:solidFill>
                   <a:srgbClr val="163A63"/>
@@ -5447,6 +5380,7 @@
           <a:lstStyle xmlns:a="http://schemas.openxmlformats.org/drawingml/2006/main"/>
           <a:p xmlns:a="http://schemas.openxmlformats.org/drawingml/2006/main">
             <a:pPr algn="ctr">
+              <a:buNone/>
               <a:defRPr sz="1425" b="1">
                 <a:solidFill>
                   <a:srgbClr val="163A63"/>
@@ -5470,6 +5404,7 @@
           </a:p>
           <a:p xmlns:a="http://schemas.openxmlformats.org/drawingml/2006/main">
             <a:pPr algn="ctr">
+              <a:buNone/>
               <a:defRPr sz="1425" b="1">
                 <a:solidFill>
                   <a:srgbClr val="163A63"/>
@@ -5551,7 +5486,7 @@
       </p:sp>
       <p:cxnSp>
         <p:nvCxnSpPr>
-          <p:cNvPr id="289" name=""/>
+          <p:cNvPr id="634" name=""/>
           <p:cNvCxnSpPr>
             <a:stCxn xmlns:a="http://schemas.openxmlformats.org/drawingml/2006/main" id="105" idx="2"/>
             <a:endCxn xmlns:a="http://schemas.openxmlformats.org/drawingml/2006/main" id="106" idx="0"/>
@@ -5633,7 +5568,7 @@
       </p:sp>
       <p:cxnSp>
         <p:nvCxnSpPr>
-          <p:cNvPr id="292" name=""/>
+          <p:cNvPr id="637" name=""/>
           <p:cNvCxnSpPr>
             <a:stCxn xmlns:a="http://schemas.openxmlformats.org/drawingml/2006/main" id="108" idx="1"/>
             <a:endCxn xmlns:a="http://schemas.openxmlformats.org/drawingml/2006/main" id="109" idx="3"/>
@@ -5715,7 +5650,7 @@
       </p:sp>
       <p:cxnSp>
         <p:nvCxnSpPr>
-          <p:cNvPr id="295" name=""/>
+          <p:cNvPr id="640" name=""/>
           <p:cNvCxnSpPr>
             <a:stCxn xmlns:a="http://schemas.openxmlformats.org/drawingml/2006/main" id="111" idx="0"/>
             <a:endCxn xmlns:a="http://schemas.openxmlformats.org/drawingml/2006/main" id="112" idx="2"/>
@@ -5797,7 +5732,7 @@
       </p:sp>
       <p:cxnSp>
         <p:nvCxnSpPr>
-          <p:cNvPr id="298" name=""/>
+          <p:cNvPr id="643" name=""/>
           <p:cNvCxnSpPr>
             <a:stCxn xmlns:a="http://schemas.openxmlformats.org/drawingml/2006/main" id="114" idx="3"/>
             <a:endCxn xmlns:a="http://schemas.openxmlformats.org/drawingml/2006/main" id="115" idx="1"/>
@@ -5855,6 +5790,7 @@
           <a:lstStyle xmlns:a="http://schemas.openxmlformats.org/drawingml/2006/main"/>
           <a:p xmlns:a="http://schemas.openxmlformats.org/drawingml/2006/main">
             <a:pPr algn="ctr">
+              <a:buNone/>
               <a:defRPr sz="1350" b="1">
                 <a:solidFill>
                   <a:srgbClr val="2166B0"/>
@@ -5943,6 +5879,7 @@
           <a:lstStyle xmlns:a="http://schemas.openxmlformats.org/drawingml/2006/main"/>
           <a:p xmlns:a="http://schemas.openxmlformats.org/drawingml/2006/main">
             <a:pPr algn="l">
+              <a:buNone/>
               <a:defRPr sz="1875" b="1">
                 <a:solidFill>
                   <a:srgbClr val="2166B0"/>
@@ -5961,7 +5898,7 @@
                 <a:ea typeface="Hiragino Sans GB"/>
                 <a:cs typeface="Hiragino Sans GB"/>
               </a:rPr>
-              <a:t>② 返回数据：限制接收速度、排队数量和正文大小</a:t>
+              <a:t>② 返回数据：限制单帧大小、排队数量和正文内存</a:t>
             </a:r>
           </a:p>
         </p:txBody>
@@ -6000,6 +5937,7 @@
           <a:lstStyle xmlns:a="http://schemas.openxmlformats.org/drawingml/2006/main"/>
           <a:p xmlns:a="http://schemas.openxmlformats.org/drawingml/2006/main">
             <a:pPr algn="ctr">
+              <a:buNone/>
               <a:defRPr sz="1650" b="1">
                 <a:solidFill>
                   <a:srgbClr val="163A63"/>
@@ -6089,6 +6027,7 @@
           <a:lstStyle xmlns:a="http://schemas.openxmlformats.org/drawingml/2006/main"/>
           <a:p xmlns:a="http://schemas.openxmlformats.org/drawingml/2006/main">
             <a:pPr algn="ctr">
+              <a:buNone/>
               <a:defRPr sz="1350" b="1">
                 <a:solidFill>
                   <a:srgbClr val="2166B0"/>
@@ -6274,6 +6213,7 @@
           <a:lstStyle xmlns:a="http://schemas.openxmlformats.org/drawingml/2006/main"/>
           <a:p xmlns:a="http://schemas.openxmlformats.org/drawingml/2006/main">
             <a:pPr algn="ctr">
+              <a:buNone/>
               <a:defRPr sz="1425" b="0">
                 <a:solidFill>
                   <a:srgbClr val="647D99"/>
@@ -6331,6 +6271,7 @@
           <a:lstStyle xmlns:a="http://schemas.openxmlformats.org/drawingml/2006/main"/>
           <a:p xmlns:a="http://schemas.openxmlformats.org/drawingml/2006/main">
             <a:pPr algn="ctr">
+              <a:buNone/>
               <a:defRPr sz="1725" b="1">
                 <a:solidFill>
                   <a:srgbClr val="163A63"/>
@@ -6349,7 +6290,7 @@
                 <a:ea typeface="Hiragino Sans GB"/>
                 <a:cs typeface="Hiragino Sans GB"/>
               </a:rPr>
-              <a:t>限制大小与速度</a:t>
+              <a:t>限制单帧接收</a:t>
             </a:r>
           </a:p>
         </p:txBody>
@@ -6420,6 +6361,7 @@
           <a:lstStyle xmlns:a="http://schemas.openxmlformats.org/drawingml/2006/main"/>
           <a:p xmlns:a="http://schemas.openxmlformats.org/drawingml/2006/main">
             <a:pPr algn="ctr">
+              <a:buNone/>
               <a:defRPr sz="1650" b="1">
                 <a:solidFill>
                   <a:srgbClr val="2166B0"/>
@@ -6501,7 +6443,7 @@
       </p:sp>
       <p:cxnSp>
         <p:nvCxnSpPr>
-          <p:cNvPr id="315" name=""/>
+          <p:cNvPr id="660" name=""/>
           <p:cNvCxnSpPr>
             <a:stCxn xmlns:a="http://schemas.openxmlformats.org/drawingml/2006/main" id="131" idx="3"/>
             <a:endCxn xmlns:a="http://schemas.openxmlformats.org/drawingml/2006/main" id="132" idx="1"/>
@@ -6559,6 +6501,7 @@
           <a:lstStyle xmlns:a="http://schemas.openxmlformats.org/drawingml/2006/main"/>
           <a:p xmlns:a="http://schemas.openxmlformats.org/drawingml/2006/main">
             <a:pPr algn="ctr">
+              <a:buNone/>
               <a:defRPr sz="1425" b="0">
                 <a:solidFill>
                   <a:srgbClr val="2D4663"/>
@@ -6577,11 +6520,12 @@
                 <a:ea typeface="Hiragino Sans GB"/>
                 <a:cs typeface="Hiragino Sans GB"/>
               </a:rPr>
-              <a:t>帧大小 + 一帧接收时限</a:t>
+              <a:t>单帧大小设上限</a:t>
             </a:r>
           </a:p>
           <a:p xmlns:a="http://schemas.openxmlformats.org/drawingml/2006/main">
             <a:pPr algn="ctr">
+              <a:buNone/>
               <a:defRPr sz="1425" b="0">
                 <a:solidFill>
                   <a:srgbClr val="2D4663"/>
@@ -6600,7 +6544,7 @@
                 <a:ea typeface="Hiragino Sans GB"/>
                 <a:cs typeface="Hiragino Sans GB"/>
               </a:rPr>
-              <a:t>每秒帧数 + 每秒字节数</a:t>
+              <a:t>每帧设置接收时限</a:t>
             </a:r>
           </a:p>
         </p:txBody>
@@ -6639,6 +6583,7 @@
           <a:lstStyle xmlns:a="http://schemas.openxmlformats.org/drawingml/2006/main"/>
           <a:p xmlns:a="http://schemas.openxmlformats.org/drawingml/2006/main">
             <a:pPr algn="ctr">
+              <a:buNone/>
               <a:defRPr sz="1725" b="1">
                 <a:solidFill>
                   <a:srgbClr val="163A63"/>
@@ -6880,7 +6825,7 @@
       </p:sp>
       <p:cxnSp>
         <p:nvCxnSpPr>
-          <p:cNvPr id="325" name=""/>
+          <p:cNvPr id="670" name=""/>
           <p:cNvCxnSpPr>
             <a:stCxn xmlns:a="http://schemas.openxmlformats.org/drawingml/2006/main" id="141" idx="3"/>
             <a:endCxn xmlns:a="http://schemas.openxmlformats.org/drawingml/2006/main" id="142" idx="1"/>
@@ -7058,7 +7003,7 @@
       </p:sp>
       <p:cxnSp>
         <p:nvCxnSpPr>
-          <p:cNvPr id="331" name=""/>
+          <p:cNvPr id="676" name=""/>
           <p:cNvCxnSpPr>
             <a:stCxn xmlns:a="http://schemas.openxmlformats.org/drawingml/2006/main" id="147" idx="2"/>
             <a:endCxn xmlns:a="http://schemas.openxmlformats.org/drawingml/2006/main" id="148" idx="0"/>
@@ -7116,6 +7061,7 @@
           <a:lstStyle xmlns:a="http://schemas.openxmlformats.org/drawingml/2006/main"/>
           <a:p xmlns:a="http://schemas.openxmlformats.org/drawingml/2006/main">
             <a:pPr algn="ctr">
+              <a:buNone/>
               <a:defRPr sz="1425" b="0">
                 <a:solidFill>
                   <a:srgbClr val="2D4663"/>
@@ -7139,6 +7085,7 @@
           </a:p>
           <a:p xmlns:a="http://schemas.openxmlformats.org/drawingml/2006/main">
             <a:pPr algn="ctr">
+              <a:buNone/>
               <a:defRPr sz="1425" b="0">
                 <a:solidFill>
                   <a:srgbClr val="2D4663"/>
@@ -7196,6 +7143,7 @@
           <a:lstStyle xmlns:a="http://schemas.openxmlformats.org/drawingml/2006/main"/>
           <a:p xmlns:a="http://schemas.openxmlformats.org/drawingml/2006/main">
             <a:pPr algn="ctr">
+              <a:buNone/>
               <a:defRPr sz="1725" b="1">
                 <a:solidFill>
                   <a:srgbClr val="163A63"/>
@@ -7547,7 +7495,7 @@
       </p:sp>
       <p:cxnSp>
         <p:nvCxnSpPr>
-          <p:cNvPr id="344" name=""/>
+          <p:cNvPr id="689" name=""/>
           <p:cNvCxnSpPr>
             <a:stCxn xmlns:a="http://schemas.openxmlformats.org/drawingml/2006/main" id="160" idx="3"/>
             <a:endCxn xmlns:a="http://schemas.openxmlformats.org/drawingml/2006/main" id="161" idx="1"/>
@@ -7629,7 +7577,7 @@
       </p:sp>
       <p:cxnSp>
         <p:nvCxnSpPr>
-          <p:cNvPr id="347" name=""/>
+          <p:cNvPr id="692" name=""/>
           <p:cNvCxnSpPr>
             <a:stCxn xmlns:a="http://schemas.openxmlformats.org/drawingml/2006/main" id="163" idx="0"/>
             <a:endCxn xmlns:a="http://schemas.openxmlformats.org/drawingml/2006/main" id="164" idx="2"/>
@@ -7711,7 +7659,7 @@
       </p:sp>
       <p:cxnSp>
         <p:nvCxnSpPr>
-          <p:cNvPr id="350" name=""/>
+          <p:cNvPr id="695" name=""/>
           <p:cNvCxnSpPr>
             <a:stCxn xmlns:a="http://schemas.openxmlformats.org/drawingml/2006/main" id="166" idx="3"/>
             <a:endCxn xmlns:a="http://schemas.openxmlformats.org/drawingml/2006/main" id="167" idx="1"/>
@@ -7769,6 +7717,7 @@
           <a:lstStyle xmlns:a="http://schemas.openxmlformats.org/drawingml/2006/main"/>
           <a:p xmlns:a="http://schemas.openxmlformats.org/drawingml/2006/main">
             <a:pPr algn="ctr">
+              <a:buNone/>
               <a:defRPr sz="1425" b="0">
                 <a:solidFill>
                   <a:srgbClr val="2D4663"/>
@@ -7792,6 +7741,7 @@
           </a:p>
           <a:p xmlns:a="http://schemas.openxmlformats.org/drawingml/2006/main">
             <a:pPr algn="ctr">
+              <a:buNone/>
               <a:defRPr sz="1425" b="0">
                 <a:solidFill>
                   <a:srgbClr val="2D4663"/>
@@ -7817,22 +7767,53 @@
       </p:sp>
       <p:sp>
         <p:nvSpPr>
-          <p:cNvPr id="170" name="text-169">
-            <a:extLst xmlns:a="http://schemas.openxmlformats.org/drawingml/2006/main">
-              <a:ext uri="{FF2B5EF4-FFF2-40B4-BE49-F238E27FC236}">
-                <a16:creationId xmlns:a16="http://schemas.microsoft.com/office/drawing/2014/main" id="{25A31637-1F49-4B5E-B7D9-B748F53BA4B4}"/>
-              </a:ext>
-            </a:extLst>
-          </p:cNvPr>
-          <p:cNvSpPr>
-            <a:spLocks xmlns:a="http://schemas.openxmlformats.org/drawingml/2006/main" noGrp="1"/>
-          </p:cNvSpPr>
-          <p:nvPr/>
-        </p:nvSpPr>
-        <p:spPr>
-          <a:xfrm xmlns:a="http://schemas.openxmlformats.org/drawingml/2006/main">
-            <a:off x="10668000" y="2028825"/>
-            <a:ext cx="4048125" cy="295275"/>
+          <p:cNvPr id="180" name="line-179">
+            <a:extLst xmlns:a="http://schemas.openxmlformats.org/drawingml/2006/main">
+              <a:ext uri="{FF2B5EF4-FFF2-40B4-BE49-F238E27FC236}">
+                <a16:creationId xmlns:a16="http://schemas.microsoft.com/office/drawing/2014/main" id="{46BCD39C-2C75-40AD-84F1-D49900BA0D7B}"/>
+              </a:ext>
+            </a:extLst>
+          </p:cNvPr>
+          <p:cNvSpPr>
+            <a:spLocks xmlns:a="http://schemas.openxmlformats.org/drawingml/2006/main" noGrp="1"/>
+          </p:cNvSpPr>
+          <p:nvPr/>
+        </p:nvSpPr>
+        <p:spPr>
+          <a:xfrm xmlns:a="http://schemas.openxmlformats.org/drawingml/2006/main">
+            <a:off x="523875" y="7800975"/>
+            <a:ext cx="14192250" cy="0"/>
+          </a:xfrm>
+          <a:prstGeom xmlns:a="http://schemas.openxmlformats.org/drawingml/2006/main" prst="line">
+            <a:avLst/>
+          </a:prstGeom>
+          <a:noFill xmlns:a="http://schemas.openxmlformats.org/drawingml/2006/main"/>
+          <a:ln xmlns:a="http://schemas.openxmlformats.org/drawingml/2006/main" w="14288">
+            <a:solidFill>
+              <a:srgbClr val="B9CEE5"/>
+            </a:solidFill>
+            <a:prstDash val="solid"/>
+          </a:ln>
+        </p:spPr>
+      </p:sp>
+      <p:sp>
+        <p:nvSpPr>
+          <p:cNvPr id="181" name="text-180">
+            <a:extLst xmlns:a="http://schemas.openxmlformats.org/drawingml/2006/main">
+              <a:ext uri="{FF2B5EF4-FFF2-40B4-BE49-F238E27FC236}">
+                <a16:creationId xmlns:a16="http://schemas.microsoft.com/office/drawing/2014/main" id="{F0AA7ED8-EDF4-43F3-83AF-AF2EC6673839}"/>
+              </a:ext>
+            </a:extLst>
+          </p:cNvPr>
+          <p:cNvSpPr>
+            <a:spLocks xmlns:a="http://schemas.openxmlformats.org/drawingml/2006/main" noGrp="1"/>
+          </p:cNvSpPr>
+          <p:nvPr/>
+        </p:nvSpPr>
+        <p:spPr>
+          <a:xfrm xmlns:a="http://schemas.openxmlformats.org/drawingml/2006/main">
+            <a:off x="533400" y="7877175"/>
+            <a:ext cx="14182725" cy="285750"/>
           </a:xfrm>
           <a:prstGeom xmlns:a="http://schemas.openxmlformats.org/drawingml/2006/main" prst="rect">
             <a:avLst/>
@@ -7849,9 +7830,10 @@
           <a:lstStyle xmlns:a="http://schemas.openxmlformats.org/drawingml/2006/main"/>
           <a:p xmlns:a="http://schemas.openxmlformats.org/drawingml/2006/main">
             <a:pPr algn="l">
-              <a:defRPr sz="1800" b="1">
-                <a:solidFill>
-                  <a:srgbClr val="2166B0"/>
+              <a:buNone/>
+              <a:defRPr sz="1500" b="0">
+                <a:solidFill>
+                  <a:srgbClr val="163A63"/>
                 </a:solidFill>
                 <a:latin typeface="Hiragino Sans GB"/>
                 <a:ea typeface="Hiragino Sans GB"/>
@@ -7859,37 +7841,37 @@
               </a:defRPr>
             </a:pPr>
             <a:r>
-              <a:rPr sz="1800" b="1">
-                <a:solidFill>
-                  <a:srgbClr val="2166B0"/>
+              <a:rPr sz="1500" b="0">
+                <a:solidFill>
+                  <a:srgbClr val="163A63"/>
                 </a:solidFill>
                 <a:latin typeface="Hiragino Sans GB"/>
                 <a:ea typeface="Hiragino Sans GB"/>
                 <a:cs typeface="Hiragino Sans GB"/>
               </a:rPr>
-              <a:t>01  并发限制与普通流超时</a:t>
+              <a:t>下游协议：三方确认数据限制、各段超时和后台任务期限并联测。符合约定却被误拒，由本方修复。</a:t>
             </a:r>
           </a:p>
         </p:txBody>
       </p:sp>
       <p:sp>
         <p:nvSpPr>
-          <p:cNvPr id="171" name="text-170">
-            <a:extLst xmlns:a="http://schemas.openxmlformats.org/drawingml/2006/main">
-              <a:ext uri="{FF2B5EF4-FFF2-40B4-BE49-F238E27FC236}">
-                <a16:creationId xmlns:a16="http://schemas.microsoft.com/office/drawing/2014/main" id="{D94EF54E-E397-4836-963D-9797E2A9934D}"/>
-              </a:ext>
-            </a:extLst>
-          </p:cNvPr>
-          <p:cNvSpPr>
-            <a:spLocks xmlns:a="http://schemas.openxmlformats.org/drawingml/2006/main" noGrp="1"/>
-          </p:cNvSpPr>
-          <p:nvPr/>
-        </p:nvSpPr>
-        <p:spPr>
-          <a:xfrm xmlns:a="http://schemas.openxmlformats.org/drawingml/2006/main">
-            <a:off x="10668000" y="2362200"/>
-            <a:ext cx="4048125" cy="742950"/>
+          <p:cNvPr id="182" name="text-181">
+            <a:extLst xmlns:a="http://schemas.openxmlformats.org/drawingml/2006/main">
+              <a:ext uri="{FF2B5EF4-FFF2-40B4-BE49-F238E27FC236}">
+                <a16:creationId xmlns:a16="http://schemas.microsoft.com/office/drawing/2014/main" id="{2FEF3F19-26FC-4953-9949-9BAFFEC5AA5F}"/>
+              </a:ext>
+            </a:extLst>
+          </p:cNvPr>
+          <p:cNvSpPr>
+            <a:spLocks xmlns:a="http://schemas.openxmlformats.org/drawingml/2006/main" noGrp="1"/>
+          </p:cNvSpPr>
+          <p:nvPr/>
+        </p:nvSpPr>
+        <p:spPr>
+          <a:xfrm xmlns:a="http://schemas.openxmlformats.org/drawingml/2006/main">
+            <a:off x="533400" y="8220075"/>
+            <a:ext cx="14182725" cy="247650"/>
           </a:xfrm>
           <a:prstGeom xmlns:a="http://schemas.openxmlformats.org/drawingml/2006/main" prst="rect">
             <a:avLst/>
@@ -7906,9 +7888,10 @@
           <a:lstStyle xmlns:a="http://schemas.openxmlformats.org/drawingml/2006/main"/>
           <a:p xmlns:a="http://schemas.openxmlformats.org/drawingml/2006/main">
             <a:pPr algn="l">
-              <a:defRPr sz="1500" b="0">
-                <a:solidFill>
-                  <a:srgbClr val="2D4663"/>
+              <a:buNone/>
+              <a:defRPr sz="1425" b="0">
+                <a:solidFill>
+                  <a:srgbClr val="647D99"/>
                 </a:solidFill>
                 <a:latin typeface="Hiragino Sans GB"/>
                 <a:ea typeface="Hiragino Sans GB"/>
@@ -7916,83 +7899,37 @@
               </a:defRPr>
             </a:pPr>
             <a:r>
-              <a:rPr sz="1500" b="0">
-                <a:solidFill>
-                  <a:srgbClr val="2D4663"/>
+              <a:rPr sz="1425" b="0">
+                <a:solidFill>
+                  <a:srgbClr val="647D99"/>
                 </a:solidFill>
                 <a:latin typeface="Hiragino Sans GB"/>
                 <a:ea typeface="Hiragino Sans GB"/>
                 <a:cs typeface="Hiragino Sans GB"/>
               </a:rPr>
-              <a:t>实例、单Agent分别限并发，满则拒绝。</a:t>
-            </a:r>
-          </a:p>
-          <a:p xmlns:a="http://schemas.openxmlformats.org/drawingml/2006/main">
-            <a:pPr algn="l">
-              <a:defRPr sz="1500" b="0">
-                <a:solidFill>
-                  <a:srgbClr val="2D4663"/>
-                </a:solidFill>
-                <a:latin typeface="Hiragino Sans GB"/>
-                <a:ea typeface="Hiragino Sans GB"/>
-                <a:cs typeface="Hiragino Sans GB"/>
-              </a:defRPr>
-            </a:pPr>
-            <a:r>
-              <a:rPr sz="1500" b="0">
-                <a:solidFill>
-                  <a:srgbClr val="2D4663"/>
-                </a:solidFill>
-                <a:latin typeface="Hiragino Sans GB"/>
-                <a:ea typeface="Hiragino Sans GB"/>
-                <a:cs typeface="Hiragino Sans GB"/>
-              </a:rPr>
-              <a:t>各阶段有超时，整次调用另设总时限。</a:t>
-            </a:r>
-          </a:p>
-          <a:p xmlns:a="http://schemas.openxmlformats.org/drawingml/2006/main">
-            <a:pPr algn="l">
-              <a:defRPr sz="1500" b="0">
-                <a:solidFill>
-                  <a:srgbClr val="2D4663"/>
-                </a:solidFill>
-                <a:latin typeface="Hiragino Sans GB"/>
-                <a:ea typeface="Hiragino Sans GB"/>
-                <a:cs typeface="Hiragino Sans GB"/>
-              </a:defRPr>
-            </a:pPr>
-            <a:r>
-              <a:rPr sz="1500" b="0">
-                <a:solidFill>
-                  <a:srgbClr val="2D4663"/>
-                </a:solidFill>
-                <a:latin typeface="Hiragino Sans GB"/>
-                <a:ea typeface="Hiragino Sans GB"/>
-                <a:cs typeface="Hiragino Sans GB"/>
-              </a:rPr>
-              <a:t>超时后停止等待，释放本地连接与名额。</a:t>
+              <a:t>本页为加固设计。后台任务限量、远端查询与取消确认待补充。连接结束不代表任务停止。FULL / no-store规则不变。</a:t>
             </a:r>
           </a:p>
         </p:txBody>
       </p:sp>
       <p:sp>
         <p:nvSpPr>
-          <p:cNvPr id="172" name="text-171">
-            <a:extLst xmlns:a="http://schemas.openxmlformats.org/drawingml/2006/main">
-              <a:ext uri="{FF2B5EF4-FFF2-40B4-BE49-F238E27FC236}">
-                <a16:creationId xmlns:a16="http://schemas.microsoft.com/office/drawing/2014/main" id="{6CCF7341-E20A-4591-91F9-84BCA32B7EAD}"/>
-              </a:ext>
-            </a:extLst>
-          </p:cNvPr>
-          <p:cNvSpPr>
-            <a:spLocks xmlns:a="http://schemas.openxmlformats.org/drawingml/2006/main" noGrp="1"/>
-          </p:cNvSpPr>
-          <p:nvPr/>
-        </p:nvSpPr>
-        <p:spPr>
-          <a:xfrm xmlns:a="http://schemas.openxmlformats.org/drawingml/2006/main">
-            <a:off x="10668000" y="3143250"/>
-            <a:ext cx="4048125" cy="295275"/>
+          <p:cNvPr id="351" name="right-group-1">
+            <a:extLst xmlns:a="http://schemas.openxmlformats.org/drawingml/2006/main">
+              <a:ext uri="{FF2B5EF4-FFF2-40B4-BE49-F238E27FC236}">
+                <a16:creationId xmlns:a16="http://schemas.microsoft.com/office/drawing/2014/main" id="{E3151E57-3A24-4759-ADC9-0B3244729C87}"/>
+              </a:ext>
+            </a:extLst>
+          </p:cNvPr>
+          <p:cNvSpPr>
+            <a:spLocks xmlns:a="http://schemas.openxmlformats.org/drawingml/2006/main" noGrp="1"/>
+          </p:cNvSpPr>
+          <p:nvPr/>
+        </p:nvSpPr>
+        <p:spPr>
+          <a:xfrm xmlns:a="http://schemas.openxmlformats.org/drawingml/2006/main">
+            <a:off x="10668000" y="1952625"/>
+            <a:ext cx="4048125" cy="323850"/>
           </a:xfrm>
           <a:prstGeom xmlns:a="http://schemas.openxmlformats.org/drawingml/2006/main" prst="rect">
             <a:avLst/>
@@ -8003,13 +7940,14 @@
           </a:ln>
         </p:spPr>
         <p:txBody>
-          <a:bodyPr xmlns:a="http://schemas.openxmlformats.org/drawingml/2006/main" lIns="0" tIns="0" rIns="0" bIns="0" anchor="ctr">
+          <a:bodyPr xmlns:a="http://schemas.openxmlformats.org/drawingml/2006/main" lIns="0" tIns="0" rIns="0" bIns="0" anchor="t">
             <a:noAutofit/>
           </a:bodyPr>
           <a:lstStyle xmlns:a="http://schemas.openxmlformats.org/drawingml/2006/main"/>
           <a:p xmlns:a="http://schemas.openxmlformats.org/drawingml/2006/main">
             <a:pPr algn="l">
-              <a:defRPr sz="1800" b="1">
+              <a:buNone/>
+              <a:defRPr sz="1875" b="1">
                 <a:solidFill>
                   <a:srgbClr val="2166B0"/>
                 </a:solidFill>
@@ -8019,7 +7957,7 @@
               </a:defRPr>
             </a:pPr>
             <a:r>
-              <a:rPr sz="1800" b="1">
+              <a:rPr sz="1875" b="1">
                 <a:solidFill>
                   <a:srgbClr val="2166B0"/>
                 </a:solidFill>
@@ -8027,29 +7965,29 @@
                 <a:ea typeface="Hiragino Sans GB"/>
                 <a:cs typeface="Hiragino Sans GB"/>
               </a:rPr>
-              <a:t>02  异步任务使用独立等待期限</a:t>
+              <a:t>① 连接与长任务控制</a:t>
             </a:r>
           </a:p>
         </p:txBody>
       </p:sp>
       <p:sp>
         <p:nvSpPr>
-          <p:cNvPr id="173" name="text-172">
-            <a:extLst xmlns:a="http://schemas.openxmlformats.org/drawingml/2006/main">
-              <a:ext uri="{FF2B5EF4-FFF2-40B4-BE49-F238E27FC236}">
-                <a16:creationId xmlns:a16="http://schemas.microsoft.com/office/drawing/2014/main" id="{C4EF6C29-A9F0-467A-B520-63ACBFE81C35}"/>
-              </a:ext>
-            </a:extLst>
-          </p:cNvPr>
-          <p:cNvSpPr>
-            <a:spLocks xmlns:a="http://schemas.openxmlformats.org/drawingml/2006/main" noGrp="1"/>
-          </p:cNvSpPr>
-          <p:nvPr/>
-        </p:nvSpPr>
-        <p:spPr>
-          <a:xfrm xmlns:a="http://schemas.openxmlformats.org/drawingml/2006/main">
-            <a:off x="10668000" y="3476625"/>
-            <a:ext cx="4048125" cy="952500"/>
+          <p:cNvPr id="352" name="right-admission">
+            <a:extLst xmlns:a="http://schemas.openxmlformats.org/drawingml/2006/main">
+              <a:ext uri="{FF2B5EF4-FFF2-40B4-BE49-F238E27FC236}">
+                <a16:creationId xmlns:a16="http://schemas.microsoft.com/office/drawing/2014/main" id="{61975D0E-AF7D-4D64-8B64-2C5761FAD74E}"/>
+              </a:ext>
+            </a:extLst>
+          </p:cNvPr>
+          <p:cNvSpPr>
+            <a:spLocks xmlns:a="http://schemas.openxmlformats.org/drawingml/2006/main" noGrp="1"/>
+          </p:cNvSpPr>
+          <p:nvPr/>
+        </p:nvSpPr>
+        <p:spPr>
+          <a:xfrm xmlns:a="http://schemas.openxmlformats.org/drawingml/2006/main">
+            <a:off x="10668000" y="2381250"/>
+            <a:ext cx="4048125" cy="552450"/>
           </a:xfrm>
           <a:prstGeom xmlns:a="http://schemas.openxmlformats.org/drawingml/2006/main" prst="rect">
             <a:avLst/>
@@ -8060,12 +7998,13 @@
           </a:ln>
         </p:spPr>
         <p:txBody>
-          <a:bodyPr xmlns:a="http://schemas.openxmlformats.org/drawingml/2006/main" lIns="0" tIns="0" rIns="0" bIns="0" anchor="ctr">
+          <a:bodyPr xmlns:a="http://schemas.openxmlformats.org/drawingml/2006/main" lIns="0" tIns="0" rIns="0" bIns="0" anchor="t">
             <a:noAutofit/>
           </a:bodyPr>
           <a:lstStyle xmlns:a="http://schemas.openxmlformats.org/drawingml/2006/main"/>
           <a:p xmlns:a="http://schemas.openxmlformats.org/drawingml/2006/main">
             <a:pPr algn="l">
+              <a:buNone/>
               <a:defRPr sz="1500" b="0">
                 <a:solidFill>
                   <a:srgbClr val="2D4663"/>
@@ -8076,7 +8015,18 @@
               </a:defRPr>
             </a:pPr>
             <a:r>
-              <a:rPr sz="1500" b="0">
+              <a:rPr sz="1500" b="1">
+                <a:solidFill>
+                  <a:srgbClr val="163A63"/>
+                </a:solidFill>
+                <a:latin typeface="Hiragino Sans GB"/>
+                <a:ea typeface="Hiragino Sans GB"/>
+                <a:cs typeface="Hiragino Sans GB"/>
+              </a:rPr>
+              <a:t>并发准入：</a:t>
+            </a:r>
+            <a:r>
+              <a:rPr sz="1500">
                 <a:solidFill>
                   <a:srgbClr val="2D4663"/>
                 </a:solidFill>
@@ -8084,11 +8034,12 @@
                 <a:ea typeface="Hiragino Sans GB"/>
                 <a:cs typeface="Hiragino Sans GB"/>
               </a:rPr>
-              <a:t>标记返回前，按普通流的期限等待。</a:t>
+              <a:t>实例、单Agent分别限并发；</a:t>
             </a:r>
           </a:p>
           <a:p xmlns:a="http://schemas.openxmlformats.org/drawingml/2006/main">
             <a:pPr algn="l">
+              <a:buNone/>
               <a:defRPr sz="1500" b="0">
                 <a:solidFill>
                   <a:srgbClr val="2D4663"/>
@@ -8099,7 +8050,7 @@
               </a:defRPr>
             </a:pPr>
             <a:r>
-              <a:rPr sz="1500" b="0">
+              <a:rPr sz="1500">
                 <a:solidFill>
                   <a:srgbClr val="2D4663"/>
                 </a:solidFill>
@@ -8107,75 +8058,29 @@
                 <a:ea typeface="Hiragino Sans GB"/>
                 <a:cs typeface="Hiragino Sans GB"/>
               </a:rPr>
-              <a:t>收到标记后结束HTTP，后台继续运行。</a:t>
-            </a:r>
-          </a:p>
-          <a:p xmlns:a="http://schemas.openxmlformats.org/drawingml/2006/main">
-            <a:pPr algn="l">
-              <a:defRPr sz="1500" b="0">
-                <a:solidFill>
-                  <a:srgbClr val="2D4663"/>
-                </a:solidFill>
-                <a:latin typeface="Hiragino Sans GB"/>
-                <a:ea typeface="Hiragino Sans GB"/>
-                <a:cs typeface="Hiragino Sans GB"/>
-              </a:defRPr>
-            </a:pPr>
-            <a:r>
-              <a:rPr sz="1500" b="0">
-                <a:solidFill>
-                  <a:srgbClr val="2D4663"/>
-                </a:solidFill>
-                <a:latin typeface="Hiragino Sans GB"/>
-                <a:ea typeface="Hiragino Sans GB"/>
-                <a:cs typeface="Hiragino Sans GB"/>
-              </a:rPr>
-              <a:t>单次回调处理限时，按runId匹配。</a:t>
-            </a:r>
-          </a:p>
-          <a:p xmlns:a="http://schemas.openxmlformats.org/drawingml/2006/main">
-            <a:pPr algn="l">
-              <a:defRPr sz="1500" b="0">
-                <a:solidFill>
-                  <a:srgbClr val="2D4663"/>
-                </a:solidFill>
-                <a:latin typeface="Hiragino Sans GB"/>
-                <a:ea typeface="Hiragino Sans GB"/>
-                <a:cs typeface="Hiragino Sans GB"/>
-              </a:defRPr>
-            </a:pPr>
-            <a:r>
-              <a:rPr sz="1500" b="0">
-                <a:solidFill>
-                  <a:srgbClr val="2D4663"/>
-                </a:solidFill>
-                <a:latin typeface="Hiragino Sans GB"/>
-                <a:ea typeface="Hiragino Sans GB"/>
-                <a:cs typeface="Hiragino Sans GB"/>
-              </a:rPr>
-              <a:t>到期结束本地任务，远端状态另确认。</a:t>
+              <a:t>达到上限则拒绝，调用结束释放资源。</a:t>
             </a:r>
           </a:p>
         </p:txBody>
       </p:sp>
       <p:sp>
         <p:nvSpPr>
-          <p:cNvPr id="174" name="text-173">
-            <a:extLst xmlns:a="http://schemas.openxmlformats.org/drawingml/2006/main">
-              <a:ext uri="{FF2B5EF4-FFF2-40B4-BE49-F238E27FC236}">
-                <a16:creationId xmlns:a16="http://schemas.microsoft.com/office/drawing/2014/main" id="{34DFBD4F-980F-429A-98D7-DCF409DBEED5}"/>
-              </a:ext>
-            </a:extLst>
-          </p:cNvPr>
-          <p:cNvSpPr>
-            <a:spLocks xmlns:a="http://schemas.openxmlformats.org/drawingml/2006/main" noGrp="1"/>
-          </p:cNvSpPr>
-          <p:nvPr/>
-        </p:nvSpPr>
-        <p:spPr>
-          <a:xfrm xmlns:a="http://schemas.openxmlformats.org/drawingml/2006/main">
-            <a:off x="10668000" y="4486275"/>
-            <a:ext cx="4048125" cy="295275"/>
+          <p:cNvPr id="353" name="right-stream-timeouts">
+            <a:extLst xmlns:a="http://schemas.openxmlformats.org/drawingml/2006/main">
+              <a:ext uri="{FF2B5EF4-FFF2-40B4-BE49-F238E27FC236}">
+                <a16:creationId xmlns:a16="http://schemas.microsoft.com/office/drawing/2014/main" id="{8D498851-A57E-4793-94E0-F9E2C2060D1E}"/>
+              </a:ext>
+            </a:extLst>
+          </p:cNvPr>
+          <p:cNvSpPr>
+            <a:spLocks xmlns:a="http://schemas.openxmlformats.org/drawingml/2006/main" noGrp="1"/>
+          </p:cNvSpPr>
+          <p:nvPr/>
+        </p:nvSpPr>
+        <p:spPr>
+          <a:xfrm xmlns:a="http://schemas.openxmlformats.org/drawingml/2006/main">
+            <a:off x="10668000" y="3171825"/>
+            <a:ext cx="4048125" cy="790575"/>
           </a:xfrm>
           <a:prstGeom xmlns:a="http://schemas.openxmlformats.org/drawingml/2006/main" prst="rect">
             <a:avLst/>
@@ -8186,15 +8091,16 @@
           </a:ln>
         </p:spPr>
         <p:txBody>
-          <a:bodyPr xmlns:a="http://schemas.openxmlformats.org/drawingml/2006/main" lIns="0" tIns="0" rIns="0" bIns="0" anchor="ctr">
+          <a:bodyPr xmlns:a="http://schemas.openxmlformats.org/drawingml/2006/main" lIns="0" tIns="0" rIns="0" bIns="0" anchor="t">
             <a:noAutofit/>
           </a:bodyPr>
           <a:lstStyle xmlns:a="http://schemas.openxmlformats.org/drawingml/2006/main"/>
           <a:p xmlns:a="http://schemas.openxmlformats.org/drawingml/2006/main">
             <a:pPr algn="l">
-              <a:defRPr sz="1800" b="1">
-                <a:solidFill>
-                  <a:srgbClr val="2166B0"/>
+              <a:buNone/>
+              <a:defRPr sz="1500" b="0">
+                <a:solidFill>
+                  <a:srgbClr val="2D4663"/>
                 </a:solidFill>
                 <a:latin typeface="Hiragino Sans GB"/>
                 <a:ea typeface="Hiragino Sans GB"/>
@@ -8202,37 +8108,96 @@
               </a:defRPr>
             </a:pPr>
             <a:r>
-              <a:rPr sz="1800" b="1">
-                <a:solidFill>
-                  <a:srgbClr val="2166B0"/>
+              <a:rPr sz="1500" b="1">
+                <a:solidFill>
+                  <a:srgbClr val="163A63"/>
                 </a:solidFill>
                 <a:latin typeface="Hiragino Sans GB"/>
                 <a:ea typeface="Hiragino Sans GB"/>
                 <a:cs typeface="Hiragino Sans GB"/>
               </a:rPr>
-              <a:t>03  后台任务限量与取消超时</a:t>
+              <a:t>普通流期限：</a:t>
+            </a:r>
+            <a:r>
+              <a:rPr sz="1500">
+                <a:solidFill>
+                  <a:srgbClr val="2D4663"/>
+                </a:solidFill>
+                <a:latin typeface="Hiragino Sans GB"/>
+                <a:ea typeface="Hiragino Sans GB"/>
+                <a:cs typeface="Hiragino Sans GB"/>
+              </a:rPr>
+              <a:t>调用前等待、建连发送、</a:t>
+            </a:r>
+          </a:p>
+          <a:p xmlns:a="http://schemas.openxmlformats.org/drawingml/2006/main">
+            <a:pPr algn="l">
+              <a:buNone/>
+              <a:defRPr sz="1500" b="0">
+                <a:solidFill>
+                  <a:srgbClr val="2D4663"/>
+                </a:solidFill>
+                <a:latin typeface="Hiragino Sans GB"/>
+                <a:ea typeface="Hiragino Sans GB"/>
+                <a:cs typeface="Hiragino Sans GB"/>
+              </a:defRPr>
+            </a:pPr>
+            <a:r>
+              <a:rPr sz="1500">
+                <a:solidFill>
+                  <a:srgbClr val="2D4663"/>
+                </a:solidFill>
+                <a:latin typeface="Hiragino Sans GB"/>
+                <a:ea typeface="Hiragino Sans GB"/>
+                <a:cs typeface="Hiragino Sans GB"/>
+              </a:rPr>
+              <a:t>首条有效响应、持续接收分别设超时；</a:t>
+            </a:r>
+          </a:p>
+          <a:p xmlns:a="http://schemas.openxmlformats.org/drawingml/2006/main">
+            <a:pPr algn="l">
+              <a:buNone/>
+              <a:defRPr sz="1500" b="0">
+                <a:solidFill>
+                  <a:srgbClr val="2D4663"/>
+                </a:solidFill>
+                <a:latin typeface="Hiragino Sans GB"/>
+                <a:ea typeface="Hiragino Sans GB"/>
+                <a:cs typeface="Hiragino Sans GB"/>
+              </a:defRPr>
+            </a:pPr>
+            <a:r>
+              <a:rPr sz="1500">
+                <a:solidFill>
+                  <a:srgbClr val="2D4663"/>
+                </a:solidFill>
+                <a:latin typeface="Hiragino Sans GB"/>
+                <a:ea typeface="Hiragino Sans GB"/>
+                <a:cs typeface="Hiragino Sans GB"/>
+              </a:rPr>
+              <a:t>全程另设总时限，心跳与重试不重置。</a:t>
             </a:r>
           </a:p>
         </p:txBody>
       </p:sp>
       <p:sp>
         <p:nvSpPr>
-          <p:cNvPr id="175" name="text-174">
-            <a:extLst xmlns:a="http://schemas.openxmlformats.org/drawingml/2006/main">
-              <a:ext uri="{FF2B5EF4-FFF2-40B4-BE49-F238E27FC236}">
-                <a16:creationId xmlns:a16="http://schemas.microsoft.com/office/drawing/2014/main" id="{7123B49D-AC80-49F6-A79A-A94FFA453474}"/>
-              </a:ext>
-            </a:extLst>
-          </p:cNvPr>
-          <p:cNvSpPr>
-            <a:spLocks xmlns:a="http://schemas.openxmlformats.org/drawingml/2006/main" noGrp="1"/>
-          </p:cNvSpPr>
-          <p:nvPr/>
-        </p:nvSpPr>
-        <p:spPr>
-          <a:xfrm xmlns:a="http://schemas.openxmlformats.org/drawingml/2006/main">
-            <a:off x="10668000" y="4819650"/>
-            <a:ext cx="4048125" cy="742950"/>
+          <p:cNvPr id="354" name="right-async">
+            <a:extLst xmlns:a="http://schemas.openxmlformats.org/drawingml/2006/main">
+              <a:ext uri="{FF2B5EF4-FFF2-40B4-BE49-F238E27FC236}">
+                <a16:creationId xmlns:a16="http://schemas.microsoft.com/office/drawing/2014/main" id="{373DFD5A-EE9E-43A7-8D7A-516CA2536BE6}"/>
+              </a:ext>
+            </a:extLst>
+          </p:cNvPr>
+          <p:cNvSpPr>
+            <a:spLocks xmlns:a="http://schemas.openxmlformats.org/drawingml/2006/main" noGrp="1"/>
+          </p:cNvSpPr>
+          <p:nvPr/>
+        </p:nvSpPr>
+        <p:spPr>
+          <a:xfrm xmlns:a="http://schemas.openxmlformats.org/drawingml/2006/main">
+            <a:off x="10668000" y="4152900"/>
+            <a:ext cx="4048125" cy="1190625"/>
           </a:xfrm>
           <a:prstGeom xmlns:a="http://schemas.openxmlformats.org/drawingml/2006/main" prst="rect">
             <a:avLst/>
@@ -8243,12 +8208,13 @@
           </a:ln>
         </p:spPr>
         <p:txBody>
-          <a:bodyPr xmlns:a="http://schemas.openxmlformats.org/drawingml/2006/main" lIns="0" tIns="0" rIns="0" bIns="0" anchor="ctr">
+          <a:bodyPr xmlns:a="http://schemas.openxmlformats.org/drawingml/2006/main" lIns="0" tIns="0" rIns="0" bIns="0" anchor="t">
             <a:noAutofit/>
           </a:bodyPr>
           <a:lstStyle xmlns:a="http://schemas.openxmlformats.org/drawingml/2006/main"/>
           <a:p xmlns:a="http://schemas.openxmlformats.org/drawingml/2006/main">
             <a:pPr algn="l">
+              <a:buNone/>
               <a:defRPr sz="1500" b="0">
                 <a:solidFill>
                   <a:srgbClr val="2D4663"/>
@@ -8259,7 +8225,18 @@
               </a:defRPr>
             </a:pPr>
             <a:r>
-              <a:rPr sz="1500" b="0">
+              <a:rPr sz="1500" b="1">
+                <a:solidFill>
+                  <a:srgbClr val="163A63"/>
+                </a:solidFill>
+                <a:latin typeface="Hiragino Sans GB"/>
+                <a:ea typeface="Hiragino Sans GB"/>
+                <a:cs typeface="Hiragino Sans GB"/>
+              </a:rPr>
+              <a:t>异步长任务：</a:t>
+            </a:r>
+            <a:r>
+              <a:rPr sz="1500">
                 <a:solidFill>
                   <a:srgbClr val="2D4663"/>
                 </a:solidFill>
@@ -8267,11 +8244,12 @@
                 <a:ea typeface="Hiragino Sans GB"/>
                 <a:cs typeface="Hiragino Sans GB"/>
               </a:rPr>
-              <a:t>按用户、租户和Agent限制未完成任务数。</a:t>
+              <a:t>标记前沿用普通流期限，</a:t>
             </a:r>
           </a:p>
           <a:p xmlns:a="http://schemas.openxmlformats.org/drawingml/2006/main">
             <a:pPr algn="l">
+              <a:buNone/>
               <a:defRPr sz="1500" b="0">
                 <a:solidFill>
                   <a:srgbClr val="2D4663"/>
@@ -8282,7 +8260,7 @@
               </a:defRPr>
             </a:pPr>
             <a:r>
-              <a:rPr sz="1500" b="0">
+              <a:rPr sz="1500">
                 <a:solidFill>
                   <a:srgbClr val="2D4663"/>
                 </a:solidFill>
@@ -8290,11 +8268,12 @@
                 <a:ea typeface="Hiragino Sans GB"/>
                 <a:cs typeface="Hiragino Sans GB"/>
               </a:rPr>
-              <a:t>达到上限，暂不发起新的后台任务。</a:t>
+              <a:t>标记后结束HTTP，按runId等待结果。</a:t>
             </a:r>
           </a:p>
           <a:p xmlns:a="http://schemas.openxmlformats.org/drawingml/2006/main">
             <a:pPr algn="l">
+              <a:buNone/>
               <a:defRPr sz="1500" b="0">
                 <a:solidFill>
                   <a:srgbClr val="2D4663"/>
@@ -8305,7 +8284,7 @@
               </a:defRPr>
             </a:pPr>
             <a:r>
-              <a:rPr sz="1500" b="0">
+              <a:rPr sz="1500">
                 <a:solidFill>
                   <a:srgbClr val="2D4663"/>
                 </a:solidFill>
@@ -8313,29 +8292,107 @@
                 <a:ea typeface="Hiragino Sans GB"/>
                 <a:cs typeface="Hiragino Sans GB"/>
               </a:rPr>
-              <a:t>取消超时先查任务状态，不自动重跑。</a:t>
+              <a:t>按用户、租户和Agent限制未完成任务数；</a:t>
+            </a:r>
+          </a:p>
+          <a:p xmlns:a="http://schemas.openxmlformats.org/drawingml/2006/main">
+            <a:pPr algn="l">
+              <a:buNone/>
+              <a:defRPr sz="1500" b="0">
+                <a:solidFill>
+                  <a:srgbClr val="2D4663"/>
+                </a:solidFill>
+                <a:latin typeface="Hiragino Sans GB"/>
+                <a:ea typeface="Hiragino Sans GB"/>
+                <a:cs typeface="Hiragino Sans GB"/>
+              </a:defRPr>
+            </a:pPr>
+            <a:r>
+              <a:rPr sz="1500">
+                <a:solidFill>
+                  <a:srgbClr val="2D4663"/>
+                </a:solidFill>
+                <a:latin typeface="Hiragino Sans GB"/>
+                <a:ea typeface="Hiragino Sans GB"/>
+                <a:cs typeface="Hiragino Sans GB"/>
+              </a:rPr>
+              <a:t>后台等待另设截止时间，到期本地结束。</a:t>
+            </a:r>
+          </a:p>
+          <a:p xmlns:a="http://schemas.openxmlformats.org/drawingml/2006/main">
+            <a:pPr algn="l">
+              <a:buNone/>
+              <a:defRPr sz="1500" b="0">
+                <a:solidFill>
+                  <a:srgbClr val="2D4663"/>
+                </a:solidFill>
+                <a:latin typeface="Hiragino Sans GB"/>
+                <a:ea typeface="Hiragino Sans GB"/>
+                <a:cs typeface="Hiragino Sans GB"/>
+              </a:defRPr>
+            </a:pPr>
+            <a:r>
+              <a:rPr sz="1500">
+                <a:solidFill>
+                  <a:srgbClr val="2D4663"/>
+                </a:solidFill>
+                <a:latin typeface="Hiragino Sans GB"/>
+                <a:ea typeface="Hiragino Sans GB"/>
+                <a:cs typeface="Hiragino Sans GB"/>
+              </a:rPr>
+              <a:t>远端状态另核对，未知结果不重跑。</a:t>
             </a:r>
           </a:p>
         </p:txBody>
       </p:sp>
       <p:sp>
         <p:nvSpPr>
-          <p:cNvPr id="176" name="text-175">
-            <a:extLst xmlns:a="http://schemas.openxmlformats.org/drawingml/2006/main">
-              <a:ext uri="{FF2B5EF4-FFF2-40B4-BE49-F238E27FC236}">
-                <a16:creationId xmlns:a16="http://schemas.microsoft.com/office/drawing/2014/main" id="{D9AB372E-817A-4069-AA84-F22EFD2D12F8}"/>
-              </a:ext>
-            </a:extLst>
-          </p:cNvPr>
-          <p:cNvSpPr>
-            <a:spLocks xmlns:a="http://schemas.openxmlformats.org/drawingml/2006/main" noGrp="1"/>
-          </p:cNvSpPr>
-          <p:nvPr/>
-        </p:nvSpPr>
-        <p:spPr>
-          <a:xfrm xmlns:a="http://schemas.openxmlformats.org/drawingml/2006/main">
-            <a:off x="10668000" y="5600700"/>
-            <a:ext cx="4048125" cy="295275"/>
+          <p:cNvPr id="355" name="right-group-divider">
+            <a:extLst xmlns:a="http://schemas.openxmlformats.org/drawingml/2006/main">
+              <a:ext uri="{FF2B5EF4-FFF2-40B4-BE49-F238E27FC236}">
+                <a16:creationId xmlns:a16="http://schemas.microsoft.com/office/drawing/2014/main" id="{0094830E-041D-4105-B690-4C35FB198886}"/>
+              </a:ext>
+            </a:extLst>
+          </p:cNvPr>
+          <p:cNvSpPr>
+            <a:spLocks xmlns:a="http://schemas.openxmlformats.org/drawingml/2006/main" noGrp="1"/>
+          </p:cNvSpPr>
+          <p:nvPr/>
+        </p:nvSpPr>
+        <p:spPr>
+          <a:xfrm xmlns:a="http://schemas.openxmlformats.org/drawingml/2006/main">
+            <a:off x="10668000" y="5391150"/>
+            <a:ext cx="4048125" cy="0"/>
+          </a:xfrm>
+          <a:prstGeom xmlns:a="http://schemas.openxmlformats.org/drawingml/2006/main" prst="line">
+            <a:avLst/>
+          </a:prstGeom>
+          <a:noFill xmlns:a="http://schemas.openxmlformats.org/drawingml/2006/main"/>
+          <a:ln xmlns:a="http://schemas.openxmlformats.org/drawingml/2006/main" w="12383">
+            <a:solidFill>
+              <a:srgbClr val="B9CEE5"/>
+            </a:solidFill>
+          </a:ln>
+        </p:spPr>
+      </p:sp>
+      <p:sp>
+        <p:nvSpPr>
+          <p:cNvPr id="356" name="right-group-2">
+            <a:extLst xmlns:a="http://schemas.openxmlformats.org/drawingml/2006/main">
+              <a:ext uri="{FF2B5EF4-FFF2-40B4-BE49-F238E27FC236}">
+                <a16:creationId xmlns:a16="http://schemas.microsoft.com/office/drawing/2014/main" id="{5B99D50E-C9E9-46CB-A8FA-D9040835CEC8}"/>
+              </a:ext>
+            </a:extLst>
+          </p:cNvPr>
+          <p:cNvSpPr>
+            <a:spLocks xmlns:a="http://schemas.openxmlformats.org/drawingml/2006/main" noGrp="1"/>
+          </p:cNvSpPr>
+          <p:nvPr/>
+        </p:nvSpPr>
+        <p:spPr>
+          <a:xfrm xmlns:a="http://schemas.openxmlformats.org/drawingml/2006/main">
+            <a:off x="10668000" y="5534025"/>
+            <a:ext cx="4048125" cy="323850"/>
           </a:xfrm>
           <a:prstGeom xmlns:a="http://schemas.openxmlformats.org/drawingml/2006/main" prst="rect">
             <a:avLst/>
@@ -8346,13 +8403,14 @@
           </a:ln>
         </p:spPr>
         <p:txBody>
-          <a:bodyPr xmlns:a="http://schemas.openxmlformats.org/drawingml/2006/main" lIns="0" tIns="0" rIns="0" bIns="0" anchor="ctr">
+          <a:bodyPr xmlns:a="http://schemas.openxmlformats.org/drawingml/2006/main" lIns="0" tIns="0" rIns="0" bIns="0" anchor="t">
             <a:noAutofit/>
           </a:bodyPr>
           <a:lstStyle xmlns:a="http://schemas.openxmlformats.org/drawingml/2006/main"/>
           <a:p xmlns:a="http://schemas.openxmlformats.org/drawingml/2006/main">
             <a:pPr algn="l">
-              <a:defRPr sz="1800" b="1">
+              <a:buNone/>
+              <a:defRPr sz="1875" b="1">
                 <a:solidFill>
                   <a:srgbClr val="2166B0"/>
                 </a:solidFill>
@@ -8362,7 +8420,7 @@
               </a:defRPr>
             </a:pPr>
             <a:r>
-              <a:rPr sz="1800" b="1">
+              <a:rPr sz="1875" b="1">
                 <a:solidFill>
                   <a:srgbClr val="2166B0"/>
                 </a:solidFill>
@@ -8370,29 +8428,29 @@
                 <a:ea typeface="Hiragino Sans GB"/>
                 <a:cs typeface="Hiragino Sans GB"/>
               </a:rPr>
-              <a:t>04  限制处理量和内存增长</a:t>
+              <a:t>② 响应结果消费控制</a:t>
             </a:r>
           </a:p>
         </p:txBody>
       </p:sp>
       <p:sp>
         <p:nvSpPr>
-          <p:cNvPr id="177" name="text-176">
-            <a:extLst xmlns:a="http://schemas.openxmlformats.org/drawingml/2006/main">
-              <a:ext uri="{FF2B5EF4-FFF2-40B4-BE49-F238E27FC236}">
-                <a16:creationId xmlns:a16="http://schemas.microsoft.com/office/drawing/2014/main" id="{26038464-3D80-478C-8E36-CFE1F6588737}"/>
-              </a:ext>
-            </a:extLst>
-          </p:cNvPr>
-          <p:cNvSpPr>
-            <a:spLocks xmlns:a="http://schemas.openxmlformats.org/drawingml/2006/main" noGrp="1"/>
-          </p:cNvSpPr>
-          <p:nvPr/>
-        </p:nvSpPr>
-        <p:spPr>
-          <a:xfrm xmlns:a="http://schemas.openxmlformats.org/drawingml/2006/main">
-            <a:off x="10668000" y="5934075"/>
-            <a:ext cx="4048125" cy="742950"/>
+          <p:cNvPr id="357" name="right-size-rate">
+            <a:extLst xmlns:a="http://schemas.openxmlformats.org/drawingml/2006/main">
+              <a:ext uri="{FF2B5EF4-FFF2-40B4-BE49-F238E27FC236}">
+                <a16:creationId xmlns:a16="http://schemas.microsoft.com/office/drawing/2014/main" id="{C444C3F7-0ED7-488D-86D9-935F552209BF}"/>
+              </a:ext>
+            </a:extLst>
+          </p:cNvPr>
+          <p:cNvSpPr>
+            <a:spLocks xmlns:a="http://schemas.openxmlformats.org/drawingml/2006/main" noGrp="1"/>
+          </p:cNvSpPr>
+          <p:nvPr/>
+        </p:nvSpPr>
+        <p:spPr>
+          <a:xfrm xmlns:a="http://schemas.openxmlformats.org/drawingml/2006/main">
+            <a:off x="10668000" y="5924550"/>
+            <a:ext cx="4048125" cy="485775"/>
           </a:xfrm>
           <a:prstGeom xmlns:a="http://schemas.openxmlformats.org/drawingml/2006/main" prst="rect">
             <a:avLst/>
@@ -8403,23 +8461,37 @@
           </a:ln>
         </p:spPr>
         <p:txBody>
-          <a:bodyPr xmlns:a="http://schemas.openxmlformats.org/drawingml/2006/main" lIns="0" tIns="0" rIns="0" bIns="0" anchor="ctr">
+          <a:bodyPr xmlns:a="http://schemas.openxmlformats.org/drawingml/2006/main" lIns="0" tIns="0" rIns="0" bIns="0" anchor="t">
             <a:noAutofit/>
           </a:bodyPr>
           <a:lstStyle xmlns:a="http://schemas.openxmlformats.org/drawingml/2006/main"/>
           <a:p xmlns:a="http://schemas.openxmlformats.org/drawingml/2006/main">
-            <a:pPr algn="l">
-              <a:defRPr sz="1500" b="0">
+            <a:r>
+              <a:rPr sz="1500" b="1">
+                <a:solidFill>
+                  <a:srgbClr val="163A63"/>
+                </a:solidFill>
+                <a:latin typeface="Hiragino Sans GB"/>
+                <a:ea typeface="Hiragino Sans GB"/>
+                <a:cs typeface="Hiragino Sans GB"/>
+              </a:rPr>
+              <a:t>单帧接收：</a:t>
+            </a:r>
+            <a:r>
+              <a:rPr sz="1500">
                 <a:solidFill>
                   <a:srgbClr val="2D4663"/>
                 </a:solidFill>
                 <a:latin typeface="Hiragino Sans GB"/>
                 <a:ea typeface="Hiragino Sans GB"/>
                 <a:cs typeface="Hiragino Sans GB"/>
-              </a:defRPr>
-            </a:pPr>
-            <a:r>
-              <a:rPr sz="1500" b="0">
+              </a:rPr>
+              <a:t>限制单帧大小；</a:t>
+            </a:r>
+          </a:p>
+          <a:p xmlns:a="http://schemas.openxmlformats.org/drawingml/2006/main">
+            <a:r>
+              <a:rPr sz="1500">
                 <a:solidFill>
                   <a:srgbClr val="2D4663"/>
                 </a:solidFill>
@@ -8427,75 +8499,29 @@
                 <a:ea typeface="Hiragino Sans GB"/>
                 <a:cs typeface="Hiragino Sans GB"/>
               </a:rPr>
-              <a:t>队列同时限制条数和字节数。</a:t>
-            </a:r>
-          </a:p>
-          <a:p xmlns:a="http://schemas.openxmlformats.org/drawingml/2006/main">
-            <a:pPr algn="l">
-              <a:defRPr sz="1500" b="0">
-                <a:solidFill>
-                  <a:srgbClr val="2D4663"/>
-                </a:solidFill>
-                <a:latin typeface="Hiragino Sans GB"/>
-                <a:ea typeface="Hiragino Sans GB"/>
-                <a:cs typeface="Hiragino Sans GB"/>
-              </a:defRPr>
-            </a:pPr>
-            <a:r>
-              <a:rPr sz="1500" b="0">
-                <a:solidFill>
-                  <a:srgbClr val="2D4663"/>
-                </a:solidFill>
-                <a:latin typeface="Hiragino Sans GB"/>
-                <a:ea typeface="Hiragino Sans GB"/>
-                <a:cs typeface="Hiragino Sans GB"/>
-              </a:rPr>
-              <a:t>最多P个任务同时处理，限制JSON层数。</a:t>
-            </a:r>
-          </a:p>
-          <a:p xmlns:a="http://schemas.openxmlformats.org/drawingml/2006/main">
-            <a:pPr algn="l">
-              <a:defRPr sz="1500" b="0">
-                <a:solidFill>
-                  <a:srgbClr val="2D4663"/>
-                </a:solidFill>
-                <a:latin typeface="Hiragino Sans GB"/>
-                <a:ea typeface="Hiragino Sans GB"/>
-                <a:cs typeface="Hiragino Sans GB"/>
-              </a:defRPr>
-            </a:pPr>
-            <a:r>
-              <a:rPr sz="1500" b="0">
-                <a:solidFill>
-                  <a:srgbClr val="2D4663"/>
-                </a:solidFill>
-                <a:latin typeface="Hiragino Sans GB"/>
-                <a:ea typeface="Hiragino Sans GB"/>
-                <a:cs typeface="Hiragino Sans GB"/>
-              </a:rPr>
-              <a:t>正文和编码副本都计入内存上限。</a:t>
+              <a:t>每帧设置接收时限。</a:t>
             </a:r>
           </a:p>
         </p:txBody>
       </p:sp>
       <p:sp>
         <p:nvSpPr>
-          <p:cNvPr id="178" name="text-177">
-            <a:extLst xmlns:a="http://schemas.openxmlformats.org/drawingml/2006/main">
-              <a:ext uri="{FF2B5EF4-FFF2-40B4-BE49-F238E27FC236}">
-                <a16:creationId xmlns:a16="http://schemas.microsoft.com/office/drawing/2014/main" id="{919C4C14-2AA9-4A3A-88A4-D6AC5ACBF5AD}"/>
-              </a:ext>
-            </a:extLst>
-          </p:cNvPr>
-          <p:cNvSpPr>
-            <a:spLocks xmlns:a="http://schemas.openxmlformats.org/drawingml/2006/main" noGrp="1"/>
-          </p:cNvSpPr>
-          <p:nvPr/>
-        </p:nvSpPr>
-        <p:spPr>
-          <a:xfrm xmlns:a="http://schemas.openxmlformats.org/drawingml/2006/main">
-            <a:off x="10668000" y="6715125"/>
-            <a:ext cx="4048125" cy="295275"/>
+          <p:cNvPr id="358" name="right-queue-processing">
+            <a:extLst xmlns:a="http://schemas.openxmlformats.org/drawingml/2006/main">
+              <a:ext uri="{FF2B5EF4-FFF2-40B4-BE49-F238E27FC236}">
+                <a16:creationId xmlns:a16="http://schemas.microsoft.com/office/drawing/2014/main" id="{366478B4-4DF7-4E9B-959A-15D8E16101B6}"/>
+              </a:ext>
+            </a:extLst>
+          </p:cNvPr>
+          <p:cNvSpPr>
+            <a:spLocks xmlns:a="http://schemas.openxmlformats.org/drawingml/2006/main" noGrp="1"/>
+          </p:cNvSpPr>
+          <p:nvPr/>
+        </p:nvSpPr>
+        <p:spPr>
+          <a:xfrm xmlns:a="http://schemas.openxmlformats.org/drawingml/2006/main">
+            <a:off x="10668000" y="6486525"/>
+            <a:ext cx="4048125" cy="695325"/>
           </a:xfrm>
           <a:prstGeom xmlns:a="http://schemas.openxmlformats.org/drawingml/2006/main" prst="rect">
             <a:avLst/>
@@ -8506,15 +8532,16 @@
           </a:ln>
         </p:spPr>
         <p:txBody>
-          <a:bodyPr xmlns:a="http://schemas.openxmlformats.org/drawingml/2006/main" lIns="0" tIns="0" rIns="0" bIns="0" anchor="ctr">
+          <a:bodyPr xmlns:a="http://schemas.openxmlformats.org/drawingml/2006/main" lIns="0" tIns="0" rIns="0" bIns="0" anchor="t">
             <a:noAutofit/>
           </a:bodyPr>
           <a:lstStyle xmlns:a="http://schemas.openxmlformats.org/drawingml/2006/main"/>
           <a:p xmlns:a="http://schemas.openxmlformats.org/drawingml/2006/main">
             <a:pPr algn="l">
-              <a:defRPr sz="1800" b="1">
-                <a:solidFill>
-                  <a:srgbClr val="2166B0"/>
+              <a:buNone/>
+              <a:defRPr sz="1500" b="0">
+                <a:solidFill>
+                  <a:srgbClr val="2D4663"/>
                 </a:solidFill>
                 <a:latin typeface="Hiragino Sans GB"/>
                 <a:ea typeface="Hiragino Sans GB"/>
@@ -8522,37 +8549,96 @@
               </a:defRPr>
             </a:pPr>
             <a:r>
-              <a:rPr sz="1800" b="1">
-                <a:solidFill>
-                  <a:srgbClr val="2166B0"/>
+              <a:rPr sz="1500" b="1">
+                <a:solidFill>
+                  <a:srgbClr val="163A63"/>
                 </a:solidFill>
                 <a:latin typeface="Hiragino Sans GB"/>
                 <a:ea typeface="Hiragino Sans GB"/>
                 <a:cs typeface="Hiragino Sans GB"/>
               </a:rPr>
-              <a:t>05  积压先暂停，超限明确报错</a:t>
+              <a:t>排队与处理：</a:t>
+            </a:r>
+            <a:r>
+              <a:rPr sz="1500">
+                <a:solidFill>
+                  <a:srgbClr val="2D4663"/>
+                </a:solidFill>
+                <a:latin typeface="Hiragino Sans GB"/>
+                <a:ea typeface="Hiragino Sans GB"/>
+                <a:cs typeface="Hiragino Sans GB"/>
+              </a:rPr>
+              <a:t>队列限条数和字节数，</a:t>
+            </a:r>
+          </a:p>
+          <a:p xmlns:a="http://schemas.openxmlformats.org/drawingml/2006/main">
+            <a:pPr algn="l">
+              <a:buNone/>
+              <a:defRPr sz="1500" b="0">
+                <a:solidFill>
+                  <a:srgbClr val="2D4663"/>
+                </a:solidFill>
+                <a:latin typeface="Hiragino Sans GB"/>
+                <a:ea typeface="Hiragino Sans GB"/>
+                <a:cs typeface="Hiragino Sans GB"/>
+              </a:defRPr>
+            </a:pPr>
+            <a:r>
+              <a:rPr sz="1500">
+                <a:solidFill>
+                  <a:srgbClr val="2D4663"/>
+                </a:solidFill>
+                <a:latin typeface="Hiragino Sans GB"/>
+                <a:ea typeface="Hiragino Sans GB"/>
+                <a:cs typeface="Hiragino Sans GB"/>
+              </a:rPr>
+              <a:t>最多P个任务并行，同Run串行。</a:t>
+            </a:r>
+          </a:p>
+          <a:p xmlns:a="http://schemas.openxmlformats.org/drawingml/2006/main">
+            <a:pPr algn="l">
+              <a:buNone/>
+              <a:defRPr sz="1500" b="0">
+                <a:solidFill>
+                  <a:srgbClr val="2D4663"/>
+                </a:solidFill>
+                <a:latin typeface="Hiragino Sans GB"/>
+                <a:ea typeface="Hiragino Sans GB"/>
+                <a:cs typeface="Hiragino Sans GB"/>
+              </a:defRPr>
+            </a:pPr>
+            <a:r>
+              <a:rPr sz="1500">
+                <a:solidFill>
+                  <a:srgbClr val="2D4663"/>
+                </a:solidFill>
+                <a:latin typeface="Hiragino Sans GB"/>
+                <a:ea typeface="Hiragino Sans GB"/>
+                <a:cs typeface="Hiragino Sans GB"/>
+              </a:rPr>
+              <a:t>积压先暂停，超限或暂停过久则报错终止。</a:t>
             </a:r>
           </a:p>
         </p:txBody>
       </p:sp>
       <p:sp>
         <p:nvSpPr>
-          <p:cNvPr id="179" name="text-178">
-            <a:extLst xmlns:a="http://schemas.openxmlformats.org/drawingml/2006/main">
-              <a:ext uri="{FF2B5EF4-FFF2-40B4-BE49-F238E27FC236}">
-                <a16:creationId xmlns:a16="http://schemas.microsoft.com/office/drawing/2014/main" id="{783C89AD-9F30-4C20-8FFC-FB4BB562864D}"/>
-              </a:ext>
-            </a:extLst>
-          </p:cNvPr>
-          <p:cNvSpPr>
-            <a:spLocks xmlns:a="http://schemas.openxmlformats.org/drawingml/2006/main" noGrp="1"/>
-          </p:cNvSpPr>
-          <p:nvPr/>
-        </p:nvSpPr>
-        <p:spPr>
-          <a:xfrm xmlns:a="http://schemas.openxmlformats.org/drawingml/2006/main">
-            <a:off x="10668000" y="7048500"/>
-            <a:ext cx="4048125" cy="742950"/>
+          <p:cNvPr id="359" name="right-body-memory">
+            <a:extLst xmlns:a="http://schemas.openxmlformats.org/drawingml/2006/main">
+              <a:ext uri="{FF2B5EF4-FFF2-40B4-BE49-F238E27FC236}">
+                <a16:creationId xmlns:a16="http://schemas.microsoft.com/office/drawing/2014/main" id="{C6B08142-ADDE-4DC5-BAEC-04C235FC87AF}"/>
+              </a:ext>
+            </a:extLst>
+          </p:cNvPr>
+          <p:cNvSpPr>
+            <a:spLocks xmlns:a="http://schemas.openxmlformats.org/drawingml/2006/main" noGrp="1"/>
+          </p:cNvSpPr>
+          <p:nvPr/>
+        </p:nvSpPr>
+        <p:spPr>
+          <a:xfrm xmlns:a="http://schemas.openxmlformats.org/drawingml/2006/main">
+            <a:off x="10668000" y="7229475"/>
+            <a:ext cx="4048125" cy="485775"/>
           </a:xfrm>
           <a:prstGeom xmlns:a="http://schemas.openxmlformats.org/drawingml/2006/main" prst="rect">
             <a:avLst/>
@@ -8563,12 +8649,13 @@
           </a:ln>
         </p:spPr>
         <p:txBody>
-          <a:bodyPr xmlns:a="http://schemas.openxmlformats.org/drawingml/2006/main" lIns="0" tIns="0" rIns="0" bIns="0" anchor="ctr">
+          <a:bodyPr xmlns:a="http://schemas.openxmlformats.org/drawingml/2006/main" lIns="0" tIns="0" rIns="0" bIns="0" anchor="t">
             <a:noAutofit/>
           </a:bodyPr>
           <a:lstStyle xmlns:a="http://schemas.openxmlformats.org/drawingml/2006/main"/>
           <a:p xmlns:a="http://schemas.openxmlformats.org/drawingml/2006/main">
             <a:pPr algn="l">
+              <a:buNone/>
               <a:defRPr sz="1500" b="0">
                 <a:solidFill>
                   <a:srgbClr val="2D4663"/>
@@ -8579,7 +8666,18 @@
               </a:defRPr>
             </a:pPr>
             <a:r>
-              <a:rPr sz="1500" b="0">
+              <a:rPr sz="1500" b="1">
+                <a:solidFill>
+                  <a:srgbClr val="163A63"/>
+                </a:solidFill>
+                <a:latin typeface="Hiragino Sans GB"/>
+                <a:ea typeface="Hiragino Sans GB"/>
+                <a:cs typeface="Hiragino Sans GB"/>
+              </a:rPr>
+              <a:t>正文内存：</a:t>
+            </a:r>
+            <a:r>
+              <a:rPr sz="1500">
                 <a:solidFill>
                   <a:srgbClr val="2D4663"/>
                 </a:solidFill>
@@ -8587,11 +8685,12 @@
                 <a:ea typeface="Hiragino Sans GB"/>
                 <a:cs typeface="Hiragino Sans GB"/>
               </a:rPr>
-              <a:t>队列接近上限时暂停接收，减少后恢复。</a:t>
+              <a:t>正文及编码副本计入Run</a:t>
             </a:r>
           </a:p>
           <a:p xmlns:a="http://schemas.openxmlformats.org/drawingml/2006/main">
             <a:pPr algn="l">
+              <a:buNone/>
               <a:defRPr sz="1500" b="0">
                 <a:solidFill>
                   <a:srgbClr val="2D4663"/>
@@ -8602,7 +8701,7 @@
               </a:defRPr>
             </a:pPr>
             <a:r>
-              <a:rPr sz="1500" b="0">
+              <a:rPr sz="1500">
                 <a:solidFill>
                   <a:srgbClr val="2D4663"/>
                 </a:solidFill>
@@ -8610,175 +8709,7 @@
                 <a:ea typeface="Hiragino Sans GB"/>
                 <a:cs typeface="Hiragino Sans GB"/>
               </a:rPr>
-              <a:t>超过上限或暂停太久，停止本次调用。</a:t>
-            </a:r>
-          </a:p>
-          <a:p xmlns:a="http://schemas.openxmlformats.org/drawingml/2006/main">
-            <a:pPr algn="l">
-              <a:defRPr sz="1500" b="0">
-                <a:solidFill>
-                  <a:srgbClr val="2D4663"/>
-                </a:solidFill>
-                <a:latin typeface="Hiragino Sans GB"/>
-                <a:ea typeface="Hiragino Sans GB"/>
-                <a:cs typeface="Hiragino Sans GB"/>
-              </a:defRPr>
-            </a:pPr>
-            <a:r>
-              <a:rPr sz="1500" b="0">
-                <a:solidFill>
-                  <a:srgbClr val="2D4663"/>
-                </a:solidFill>
-                <a:latin typeface="Hiragino Sans GB"/>
-                <a:ea typeface="Hiragino Sans GB"/>
-                <a:cs typeface="Hiragino Sans GB"/>
-              </a:rPr>
-              <a:t>不丢帧、不截断后再向前端报告成功。</a:t>
-            </a:r>
-          </a:p>
-        </p:txBody>
-      </p:sp>
-      <p:sp>
-        <p:nvSpPr>
-          <p:cNvPr id="180" name="line-179">
-            <a:extLst xmlns:a="http://schemas.openxmlformats.org/drawingml/2006/main">
-              <a:ext uri="{FF2B5EF4-FFF2-40B4-BE49-F238E27FC236}">
-                <a16:creationId xmlns:a16="http://schemas.microsoft.com/office/drawing/2014/main" id="{46BCD39C-2C75-40AD-84F1-D49900BA0D7B}"/>
-              </a:ext>
-            </a:extLst>
-          </p:cNvPr>
-          <p:cNvSpPr>
-            <a:spLocks xmlns:a="http://schemas.openxmlformats.org/drawingml/2006/main" noGrp="1"/>
-          </p:cNvSpPr>
-          <p:nvPr/>
-        </p:nvSpPr>
-        <p:spPr>
-          <a:xfrm xmlns:a="http://schemas.openxmlformats.org/drawingml/2006/main">
-            <a:off x="523875" y="7800975"/>
-            <a:ext cx="14192250" cy="0"/>
-          </a:xfrm>
-          <a:prstGeom xmlns:a="http://schemas.openxmlformats.org/drawingml/2006/main" prst="line">
-            <a:avLst/>
-          </a:prstGeom>
-          <a:noFill xmlns:a="http://schemas.openxmlformats.org/drawingml/2006/main"/>
-          <a:ln xmlns:a="http://schemas.openxmlformats.org/drawingml/2006/main" w="14288">
-            <a:solidFill>
-              <a:srgbClr val="B9CEE5"/>
-            </a:solidFill>
-            <a:prstDash val="solid"/>
-          </a:ln>
-        </p:spPr>
-      </p:sp>
-      <p:sp>
-        <p:nvSpPr>
-          <p:cNvPr id="181" name="text-180">
-            <a:extLst xmlns:a="http://schemas.openxmlformats.org/drawingml/2006/main">
-              <a:ext uri="{FF2B5EF4-FFF2-40B4-BE49-F238E27FC236}">
-                <a16:creationId xmlns:a16="http://schemas.microsoft.com/office/drawing/2014/main" id="{F0AA7ED8-EDF4-43F3-83AF-AF2EC6673839}"/>
-              </a:ext>
-            </a:extLst>
-          </p:cNvPr>
-          <p:cNvSpPr>
-            <a:spLocks xmlns:a="http://schemas.openxmlformats.org/drawingml/2006/main" noGrp="1"/>
-          </p:cNvSpPr>
-          <p:nvPr/>
-        </p:nvSpPr>
-        <p:spPr>
-          <a:xfrm xmlns:a="http://schemas.openxmlformats.org/drawingml/2006/main">
-            <a:off x="533400" y="7877175"/>
-            <a:ext cx="14182725" cy="285750"/>
-          </a:xfrm>
-          <a:prstGeom xmlns:a="http://schemas.openxmlformats.org/drawingml/2006/main" prst="rect">
-            <a:avLst/>
-          </a:prstGeom>
-          <a:noFill xmlns:a="http://schemas.openxmlformats.org/drawingml/2006/main"/>
-          <a:ln xmlns:a="http://schemas.openxmlformats.org/drawingml/2006/main" w="0">
-            <a:noFill/>
-          </a:ln>
-        </p:spPr>
-        <p:txBody>
-          <a:bodyPr xmlns:a="http://schemas.openxmlformats.org/drawingml/2006/main" lIns="0" tIns="0" rIns="0" bIns="0" anchor="ctr">
-            <a:noAutofit/>
-          </a:bodyPr>
-          <a:lstStyle xmlns:a="http://schemas.openxmlformats.org/drawingml/2006/main"/>
-          <a:p xmlns:a="http://schemas.openxmlformats.org/drawingml/2006/main">
-            <a:pPr algn="l">
-              <a:defRPr sz="1500" b="0">
-                <a:solidFill>
-                  <a:srgbClr val="163A63"/>
-                </a:solidFill>
-                <a:latin typeface="Hiragino Sans GB"/>
-                <a:ea typeface="Hiragino Sans GB"/>
-                <a:cs typeface="Hiragino Sans GB"/>
-              </a:defRPr>
-            </a:pPr>
-            <a:r>
-              <a:rPr sz="1500" b="0">
-                <a:solidFill>
-                  <a:srgbClr val="163A63"/>
-                </a:solidFill>
-                <a:latin typeface="Hiragino Sans GB"/>
-                <a:ea typeface="Hiragino Sans GB"/>
-                <a:cs typeface="Hiragino Sans GB"/>
-              </a:rPr>
-              <a:t>下游协议：三方确认数据限制、各段超时和后台任务期限并联测。符合约定却被误拒，由本方修复。</a:t>
-            </a:r>
-          </a:p>
-        </p:txBody>
-      </p:sp>
-      <p:sp>
-        <p:nvSpPr>
-          <p:cNvPr id="182" name="text-181">
-            <a:extLst xmlns:a="http://schemas.openxmlformats.org/drawingml/2006/main">
-              <a:ext uri="{FF2B5EF4-FFF2-40B4-BE49-F238E27FC236}">
-                <a16:creationId xmlns:a16="http://schemas.microsoft.com/office/drawing/2014/main" id="{2FEF3F19-26FC-4953-9949-9BAFFEC5AA5F}"/>
-              </a:ext>
-            </a:extLst>
-          </p:cNvPr>
-          <p:cNvSpPr>
-            <a:spLocks xmlns:a="http://schemas.openxmlformats.org/drawingml/2006/main" noGrp="1"/>
-          </p:cNvSpPr>
-          <p:nvPr/>
-        </p:nvSpPr>
-        <p:spPr>
-          <a:xfrm xmlns:a="http://schemas.openxmlformats.org/drawingml/2006/main">
-            <a:off x="533400" y="8220075"/>
-            <a:ext cx="14182725" cy="247650"/>
-          </a:xfrm>
-          <a:prstGeom xmlns:a="http://schemas.openxmlformats.org/drawingml/2006/main" prst="rect">
-            <a:avLst/>
-          </a:prstGeom>
-          <a:noFill xmlns:a="http://schemas.openxmlformats.org/drawingml/2006/main"/>
-          <a:ln xmlns:a="http://schemas.openxmlformats.org/drawingml/2006/main" w="0">
-            <a:noFill/>
-          </a:ln>
-        </p:spPr>
-        <p:txBody>
-          <a:bodyPr xmlns:a="http://schemas.openxmlformats.org/drawingml/2006/main" lIns="0" tIns="0" rIns="0" bIns="0" anchor="ctr">
-            <a:noAutofit/>
-          </a:bodyPr>
-          <a:lstStyle xmlns:a="http://schemas.openxmlformats.org/drawingml/2006/main"/>
-          <a:p xmlns:a="http://schemas.openxmlformats.org/drawingml/2006/main">
-            <a:pPr algn="l">
-              <a:defRPr sz="1425" b="0">
-                <a:solidFill>
-                  <a:srgbClr val="647D99"/>
-                </a:solidFill>
-                <a:latin typeface="Hiragino Sans GB"/>
-                <a:ea typeface="Hiragino Sans GB"/>
-                <a:cs typeface="Hiragino Sans GB"/>
-              </a:defRPr>
-            </a:pPr>
-            <a:r>
-              <a:rPr sz="1425" b="0">
-                <a:solidFill>
-                  <a:srgbClr val="647D99"/>
-                </a:solidFill>
-                <a:latin typeface="Hiragino Sans GB"/>
-                <a:ea typeface="Hiragino Sans GB"/>
-                <a:cs typeface="Hiragino Sans GB"/>
-              </a:rPr>
-              <a:t>本页为加固设计。后台任务限量、远端查询与取消确认待补充。连接结束不代表任务停止。FULL / no-store规则不变。</a:t>
+              <a:t>与实例上限；超限报错，不截断。</a:t>
             </a:r>
           </a:p>
         </p:txBody>

</xml_diff>

<commit_message>
docs: clarify incomplete message timeout in HA presentation
</commit_message>
<xml_diff>
--- a/docs/presentations/Agent高可用加固.pptx
+++ b/docs/presentations/Agent高可用加固.pptx
@@ -2,13 +2,13 @@
 <file path=ppt/presentation.xml><?xml version="1.0" encoding="utf-8"?>
 <p:presentation xmlns:p="http://schemas.openxmlformats.org/presentationml/2006/main">
   <p:sldMasterIdLst>
-    <p:sldMasterId xmlns:r="http://schemas.openxmlformats.org/officeDocument/2006/relationships" id="2147483648" r:id="R52b20cd093614509"/>
+    <p:sldMasterId xmlns:r="http://schemas.openxmlformats.org/officeDocument/2006/relationships" id="2147483648" r:id="Rdaaca6f61a3c4eed"/>
   </p:sldMasterIdLst>
   <p:notesMasterIdLst>
-    <p:notesMasterId xmlns:r="http://schemas.openxmlformats.org/officeDocument/2006/relationships" r:id="Rbe278d6521514525"/>
+    <p:notesMasterId xmlns:r="http://schemas.openxmlformats.org/officeDocument/2006/relationships" r:id="R493329723b3c4388"/>
   </p:notesMasterIdLst>
   <p:sldIdLst>
-    <p:sldId xmlns:r="http://schemas.openxmlformats.org/officeDocument/2006/relationships" id="256" r:id="R0ac4de4f1c2c451a"/>
+    <p:sldId xmlns:r="http://schemas.openxmlformats.org/officeDocument/2006/relationships" id="256" r:id="Rcd07613d55904504"/>
   </p:sldIdLst>
   <p:sldSz cx="15240000" cy="8572500"/>
   <p:notesSz cx="6858000" cy="9144000"/>
@@ -612,7 +612,7 @@
           </a:p>
           <a:p xmlns:a="http://schemas.openxmlformats.org/drawingml/2006/main">
             <a:r>
-              <a:t>首条有效响应由三方契约定义，不要求必须是首段正文。合法agent.async_started属于异步受理的有效响应，心跳与空字节不能替代。数据空闲时限限制相邻原始数据之间的停顿。单帧接收时限从该帧起始计算，收到零碎字节不能刷新它；最大帧字节数独立执行。从调用前起算的绝对总时限不因任何数据、心跳或重试重置。仅对双方协议允许的安全请求重试，重试也消费剩余总时限；未知副作用不得自动重放。自发背压暂停与网络空闲应分开计量，暂停期限独立限制且绝对总时限继续走时，避免误判下游责任。</a:t>
+              <a:t>首条有效响应由三方契约定义，不要求必须是首段正文。合法agent.async_started属于异步受理的有效响应，心跳与空字节不能替代。数据空闲时限限制相邻原始数据之间的停顿。消息接收时限从一条业务消息首字节到达到完整接收结束计时；超时仍未收完整时终止本次调用并报错。零碎字节不能反复刷新期限，这不是要求Agent固定间隔生成消息。帧按协议的完整业务消息界定，不按单次网络读取的chunk划分；单帧大小上限独立执行。从调用前起算的绝对总时限不因任何数据、心跳或重试重置。仅对双方协议允许的安全请求重试，重试也消费剩余总时限；未知副作用不得自动重放。自发背压暂停与网络空闲应分开计量，暂停期限独立限制且绝对总时限继续走时，避免误判下游责任。</a:t>
             </a:r>
           </a:p>
           <a:p xmlns:a="http://schemas.openxmlformats.org/drawingml/2006/main">
@@ -795,7 +795,7 @@
   </p:cSld>
   <p:clrMap bg1="lt1" tx1="dk1" bg2="lt2" tx2="dk2" accent1="accent1" accent2="accent2" accent3="accent3" accent4="accent4" accent5="accent5" accent6="accent6" hlink="hlink" folHlink="folHlink"/>
   <p:sldLayoutIdLst>
-    <p:sldLayoutId xmlns:r="http://schemas.openxmlformats.org/officeDocument/2006/relationships" id="2147483649" r:id="R0dfa498bb8f84a06"/>
+    <p:sldLayoutId xmlns:r="http://schemas.openxmlformats.org/officeDocument/2006/relationships" id="2147483649" r:id="Red57d21d9bc04520"/>
   </p:sldLayoutIdLst>
   <p:txStyles>
     <p:titleStyle>
@@ -2211,7 +2211,7 @@
       </p:sp>
       <p:cxnSp>
         <p:nvCxnSpPr>
-          <p:cNvPr id="549" name=""/>
+          <p:cNvPr id="717" name=""/>
           <p:cNvCxnSpPr>
             <a:stCxn xmlns:a="http://schemas.openxmlformats.org/drawingml/2006/main" id="20" idx="3"/>
             <a:endCxn xmlns:a="http://schemas.openxmlformats.org/drawingml/2006/main" id="21" idx="1"/>
@@ -2445,7 +2445,7 @@
       </p:sp>
       <p:cxnSp>
         <p:nvCxnSpPr>
-          <p:cNvPr id="556" name=""/>
+          <p:cNvPr id="724" name=""/>
           <p:cNvCxnSpPr>
             <a:stCxn xmlns:a="http://schemas.openxmlformats.org/drawingml/2006/main" id="27" idx="3"/>
             <a:endCxn xmlns:a="http://schemas.openxmlformats.org/drawingml/2006/main" id="28" idx="1"/>
@@ -2962,7 +2962,7 @@
       </p:sp>
       <p:cxnSp>
         <p:nvCxnSpPr>
-          <p:cNvPr id="571" name=""/>
+          <p:cNvPr id="739" name=""/>
           <p:cNvCxnSpPr>
             <a:stCxn xmlns:a="http://schemas.openxmlformats.org/drawingml/2006/main" id="42" idx="3"/>
             <a:endCxn xmlns:a="http://schemas.openxmlformats.org/drawingml/2006/main" id="43" idx="1"/>
@@ -3134,7 +3134,7 @@
       </p:sp>
       <p:cxnSp>
         <p:nvCxnSpPr>
-          <p:cNvPr id="576" name=""/>
+          <p:cNvPr id="744" name=""/>
           <p:cNvCxnSpPr>
             <a:stCxn xmlns:a="http://schemas.openxmlformats.org/drawingml/2006/main" id="47" idx="3"/>
             <a:endCxn xmlns:a="http://schemas.openxmlformats.org/drawingml/2006/main" id="48" idx="1"/>
@@ -3791,7 +3791,7 @@
                 <a:ea typeface="Hiragino Sans GB"/>
                 <a:cs typeface="Hiragino Sans GB"/>
               </a:rPr>
-              <a:t>空闲时限 / 一帧接收时限</a:t>
+              <a:t>空闲时限 / 消息接收时限</a:t>
             </a:r>
           </a:p>
         </p:txBody>
@@ -3854,7 +3854,7 @@
       </p:sp>
       <p:cxnSp>
         <p:nvCxnSpPr>
-          <p:cNvPr id="590" name=""/>
+          <p:cNvPr id="758" name=""/>
           <p:cNvCxnSpPr>
             <a:stCxn xmlns:a="http://schemas.openxmlformats.org/drawingml/2006/main" id="61" idx="3"/>
             <a:endCxn xmlns:a="http://schemas.openxmlformats.org/drawingml/2006/main" id="62" idx="1"/>
@@ -3936,7 +3936,7 @@
       </p:sp>
       <p:cxnSp>
         <p:nvCxnSpPr>
-          <p:cNvPr id="593" name=""/>
+          <p:cNvPr id="761" name=""/>
           <p:cNvCxnSpPr>
             <a:stCxn xmlns:a="http://schemas.openxmlformats.org/drawingml/2006/main" id="64" idx="3"/>
             <a:endCxn xmlns:a="http://schemas.openxmlformats.org/drawingml/2006/main" id="65" idx="1"/>
@@ -4018,7 +4018,7 @@
       </p:sp>
       <p:cxnSp>
         <p:nvCxnSpPr>
-          <p:cNvPr id="596" name=""/>
+          <p:cNvPr id="764" name=""/>
           <p:cNvCxnSpPr>
             <a:stCxn xmlns:a="http://schemas.openxmlformats.org/drawingml/2006/main" id="67" idx="3"/>
             <a:endCxn xmlns:a="http://schemas.openxmlformats.org/drawingml/2006/main" id="68" idx="1"/>
@@ -4100,7 +4100,7 @@
       </p:sp>
       <p:cxnSp>
         <p:nvCxnSpPr>
-          <p:cNvPr id="599" name=""/>
+          <p:cNvPr id="767" name=""/>
           <p:cNvCxnSpPr>
             <a:stCxn xmlns:a="http://schemas.openxmlformats.org/drawingml/2006/main" id="70" idx="2"/>
             <a:endCxn xmlns:a="http://schemas.openxmlformats.org/drawingml/2006/main" id="71" idx="0"/>
@@ -4182,7 +4182,7 @@
       </p:sp>
       <p:cxnSp>
         <p:nvCxnSpPr>
-          <p:cNvPr id="602" name=""/>
+          <p:cNvPr id="770" name=""/>
           <p:cNvCxnSpPr>
             <a:stCxn xmlns:a="http://schemas.openxmlformats.org/drawingml/2006/main" id="73" idx="3"/>
             <a:endCxn xmlns:a="http://schemas.openxmlformats.org/drawingml/2006/main" id="74" idx="1"/>
@@ -4264,7 +4264,7 @@
       </p:sp>
       <p:cxnSp>
         <p:nvCxnSpPr>
-          <p:cNvPr id="605" name=""/>
+          <p:cNvPr id="773" name=""/>
           <p:cNvCxnSpPr>
             <a:stCxn xmlns:a="http://schemas.openxmlformats.org/drawingml/2006/main" id="76" idx="0"/>
             <a:endCxn xmlns:a="http://schemas.openxmlformats.org/drawingml/2006/main" id="77" idx="2"/>
@@ -4730,7 +4730,7 @@
       </p:sp>
       <p:cxnSp>
         <p:nvCxnSpPr>
-          <p:cNvPr id="616" name=""/>
+          <p:cNvPr id="784" name=""/>
           <p:cNvCxnSpPr>
             <a:stCxn xmlns:a="http://schemas.openxmlformats.org/drawingml/2006/main" id="87" idx="3"/>
             <a:endCxn xmlns:a="http://schemas.openxmlformats.org/drawingml/2006/main" id="88" idx="1"/>
@@ -5486,7 +5486,7 @@
       </p:sp>
       <p:cxnSp>
         <p:nvCxnSpPr>
-          <p:cNvPr id="634" name=""/>
+          <p:cNvPr id="802" name=""/>
           <p:cNvCxnSpPr>
             <a:stCxn xmlns:a="http://schemas.openxmlformats.org/drawingml/2006/main" id="105" idx="2"/>
             <a:endCxn xmlns:a="http://schemas.openxmlformats.org/drawingml/2006/main" id="106" idx="0"/>
@@ -5568,7 +5568,7 @@
       </p:sp>
       <p:cxnSp>
         <p:nvCxnSpPr>
-          <p:cNvPr id="637" name=""/>
+          <p:cNvPr id="805" name=""/>
           <p:cNvCxnSpPr>
             <a:stCxn xmlns:a="http://schemas.openxmlformats.org/drawingml/2006/main" id="108" idx="1"/>
             <a:endCxn xmlns:a="http://schemas.openxmlformats.org/drawingml/2006/main" id="109" idx="3"/>
@@ -5650,7 +5650,7 @@
       </p:sp>
       <p:cxnSp>
         <p:nvCxnSpPr>
-          <p:cNvPr id="640" name=""/>
+          <p:cNvPr id="808" name=""/>
           <p:cNvCxnSpPr>
             <a:stCxn xmlns:a="http://schemas.openxmlformats.org/drawingml/2006/main" id="111" idx="0"/>
             <a:endCxn xmlns:a="http://schemas.openxmlformats.org/drawingml/2006/main" id="112" idx="2"/>
@@ -5732,7 +5732,7 @@
       </p:sp>
       <p:cxnSp>
         <p:nvCxnSpPr>
-          <p:cNvPr id="643" name=""/>
+          <p:cNvPr id="811" name=""/>
           <p:cNvCxnSpPr>
             <a:stCxn xmlns:a="http://schemas.openxmlformats.org/drawingml/2006/main" id="114" idx="3"/>
             <a:endCxn xmlns:a="http://schemas.openxmlformats.org/drawingml/2006/main" id="115" idx="1"/>
@@ -6443,7 +6443,7 @@
       </p:sp>
       <p:cxnSp>
         <p:nvCxnSpPr>
-          <p:cNvPr id="660" name=""/>
+          <p:cNvPr id="828" name=""/>
           <p:cNvCxnSpPr>
             <a:stCxn xmlns:a="http://schemas.openxmlformats.org/drawingml/2006/main" id="131" idx="3"/>
             <a:endCxn xmlns:a="http://schemas.openxmlformats.org/drawingml/2006/main" id="132" idx="1"/>
@@ -6544,7 +6544,7 @@
                 <a:ea typeface="Hiragino Sans GB"/>
                 <a:cs typeface="Hiragino Sans GB"/>
               </a:rPr>
-              <a:t>每帧设置接收时限</a:t>
+              <a:t>单条消息超时未收完整则终止</a:t>
             </a:r>
           </a:p>
         </p:txBody>
@@ -6825,7 +6825,7 @@
       </p:sp>
       <p:cxnSp>
         <p:nvCxnSpPr>
-          <p:cNvPr id="670" name=""/>
+          <p:cNvPr id="838" name=""/>
           <p:cNvCxnSpPr>
             <a:stCxn xmlns:a="http://schemas.openxmlformats.org/drawingml/2006/main" id="141" idx="3"/>
             <a:endCxn xmlns:a="http://schemas.openxmlformats.org/drawingml/2006/main" id="142" idx="1"/>
@@ -7003,7 +7003,7 @@
       </p:sp>
       <p:cxnSp>
         <p:nvCxnSpPr>
-          <p:cNvPr id="676" name=""/>
+          <p:cNvPr id="844" name=""/>
           <p:cNvCxnSpPr>
             <a:stCxn xmlns:a="http://schemas.openxmlformats.org/drawingml/2006/main" id="147" idx="2"/>
             <a:endCxn xmlns:a="http://schemas.openxmlformats.org/drawingml/2006/main" id="148" idx="0"/>
@@ -7495,7 +7495,7 @@
       </p:sp>
       <p:cxnSp>
         <p:nvCxnSpPr>
-          <p:cNvPr id="689" name=""/>
+          <p:cNvPr id="857" name=""/>
           <p:cNvCxnSpPr>
             <a:stCxn xmlns:a="http://schemas.openxmlformats.org/drawingml/2006/main" id="160" idx="3"/>
             <a:endCxn xmlns:a="http://schemas.openxmlformats.org/drawingml/2006/main" id="161" idx="1"/>
@@ -7577,7 +7577,7 @@
       </p:sp>
       <p:cxnSp>
         <p:nvCxnSpPr>
-          <p:cNvPr id="692" name=""/>
+          <p:cNvPr id="860" name=""/>
           <p:cNvCxnSpPr>
             <a:stCxn xmlns:a="http://schemas.openxmlformats.org/drawingml/2006/main" id="163" idx="0"/>
             <a:endCxn xmlns:a="http://schemas.openxmlformats.org/drawingml/2006/main" id="164" idx="2"/>
@@ -7659,7 +7659,7 @@
       </p:sp>
       <p:cxnSp>
         <p:nvCxnSpPr>
-          <p:cNvPr id="695" name=""/>
+          <p:cNvPr id="863" name=""/>
           <p:cNvCxnSpPr>
             <a:stCxn xmlns:a="http://schemas.openxmlformats.org/drawingml/2006/main" id="166" idx="3"/>
             <a:endCxn xmlns:a="http://schemas.openxmlformats.org/drawingml/2006/main" id="167" idx="1"/>
@@ -8499,7 +8499,7 @@
                 <a:ea typeface="Hiragino Sans GB"/>
                 <a:cs typeface="Hiragino Sans GB"/>
               </a:rPr>
-              <a:t>每帧设置接收时限。</a:t>
+              <a:t>单条消息超时未收完整，终止本次调用。</a:t>
             </a:r>
           </a:p>
         </p:txBody>

</xml_diff>